<commit_message>
Add a fill-in Word answer form for the DBGI decisions
Build "DBGI Portal Answer Form.docx" with WordCraft content controls:
name, area, and date fields, then one table per part with a drop-down
of each question's choices (plus keep today, other, and skip), a notes
box, and the question's slide number in the portal deck. It reads the
same Markdown as the deck and the printable sheet.

Point the deck's intro and reply slides at the form.

Co-Authored-By: Claude Opus 5.5 <noreply@anthropic.com>
</commit_message>
<xml_diff>
--- a/docs/guides/Portal User Guide/Using the DBGI Portal.pptx
+++ b/docs/guides/Portal User Guide/Using the DBGI Portal.pptx
@@ -14105,7 +14105,7 @@
                   <a:srgbClr val="FFFFFF"/>
                 </a:solidFill>
               </a:rPr>
-              <a:t>Reply to the person who sent you this deck, one line per question: B2: a</a:t>
+              <a:t>Answer in the Word answer form sent with this deck, or by email, one line per question: B2: a</a:t>
             </a:r>
             <a:endParaRPr sz="1600" b="0">
               <a:solidFill>
@@ -40785,7 +40785,7 @@
                   <a:srgbClr val="5B6B7A"/>
                 </a:solidFill>
               </a:rPr>
-              <a:t>Copy these lines into your reply email and fill in what you can</a:t>
+              <a:t>Easiest: fill in the Word answer form. Or copy these lines into an email.</a:t>
             </a:r>
             <a:endParaRPr sz="1400" b="0">
               <a:solidFill>
@@ -41397,7 +41397,7 @@
                   <a:srgbClr val="12384D"/>
                 </a:solidFill>
               </a:rPr>
-              <a:t>Prefer paper? The printable sheet "DBGI Portal Decisions" has the same questions with tick boxes.</a:t>
+              <a:t>"DBGI Portal Answer Form" (Word) has a drop-down for each question. Save it and send it back.</a:t>
             </a:r>
             <a:endParaRPr sz="1300" b="0">
               <a:solidFill>

</xml_diff>

<commit_message>
Reframe the decision questions for a first-ever system
DBGI has no deal registration system today; the portal will be the
first. A2 asked how deals are handled without the portal, so replace
it with what happens to deals partners reported before launch: the
portal ranks only by its own submission time and cannot record an
earlier date. Reword A1, A5, and D1 to ask what DBGI wants rather than
what it does today, and rebuild the deck, answer form, and sheet.

Co-Authored-By: Claude Opus 5.5 <noreply@anthropic.com>
</commit_message>
<xml_diff>
--- a/docs/guides/Portal User Guide/Using the DBGI Portal.pptx
+++ b/docs/guides/Portal User Guide/Using the DBGI Portal.pptx
@@ -3028,7 +3028,7 @@
       </p:sp>
       <p:sp>
         <p:nvSpPr>
-          <p:cNvPr id="1044" name="Slide Number Placeholder"/>
+          <p:cNvPr id="1051" name="Slide Number Placeholder"/>
           <p:cNvSpPr>
             <a:spLocks noGrp="1"/>
           </p:cNvSpPr>
@@ -3603,7 +3603,7 @@
       </p:sp>
       <p:sp>
         <p:nvSpPr>
-          <p:cNvPr id="1071" name="Slide Number Placeholder"/>
+          <p:cNvPr id="1078" name="Slide Number Placeholder"/>
           <p:cNvSpPr>
             <a:spLocks noGrp="1"/>
           </p:cNvSpPr>
@@ -4173,7 +4173,7 @@
       </p:sp>
       <p:sp>
         <p:nvSpPr>
-          <p:cNvPr id="1074" name="Slide Number Placeholder"/>
+          <p:cNvPr id="1081" name="Slide Number Placeholder"/>
           <p:cNvSpPr>
             <a:spLocks noGrp="1"/>
           </p:cNvSpPr>
@@ -4725,7 +4725,7 @@
       </p:sp>
       <p:sp>
         <p:nvSpPr>
-          <p:cNvPr id="1077" name="Slide Number Placeholder"/>
+          <p:cNvPr id="1084" name="Slide Number Placeholder"/>
           <p:cNvSpPr>
             <a:spLocks noGrp="1"/>
           </p:cNvSpPr>
@@ -5650,7 +5650,7 @@
       </p:sp>
       <p:sp>
         <p:nvSpPr>
-          <p:cNvPr id="1080" name="Slide Number Placeholder"/>
+          <p:cNvPr id="1087" name="Slide Number Placeholder"/>
           <p:cNvSpPr>
             <a:spLocks noGrp="1"/>
           </p:cNvSpPr>
@@ -6231,7 +6231,7 @@
       </p:sp>
       <p:sp>
         <p:nvSpPr>
-          <p:cNvPr id="1083" name="Slide Number Placeholder"/>
+          <p:cNvPr id="1090" name="Slide Number Placeholder"/>
           <p:cNvSpPr>
             <a:spLocks noGrp="1"/>
           </p:cNvSpPr>
@@ -6812,7 +6812,7 @@
       </p:sp>
       <p:sp>
         <p:nvSpPr>
-          <p:cNvPr id="1086" name="Slide Number Placeholder"/>
+          <p:cNvPr id="1093" name="Slide Number Placeholder"/>
           <p:cNvSpPr>
             <a:spLocks noGrp="1"/>
           </p:cNvSpPr>
@@ -7390,7 +7390,7 @@
       </p:sp>
       <p:sp>
         <p:nvSpPr>
-          <p:cNvPr id="1089" name="Slide Number Placeholder"/>
+          <p:cNvPr id="1096" name="Slide Number Placeholder"/>
           <p:cNvSpPr>
             <a:spLocks noGrp="1"/>
           </p:cNvSpPr>
@@ -8019,7 +8019,7 @@
       </p:sp>
       <p:sp>
         <p:nvSpPr>
-          <p:cNvPr id="1092" name="Slide Number Placeholder"/>
+          <p:cNvPr id="1099" name="Slide Number Placeholder"/>
           <p:cNvSpPr>
             <a:spLocks noGrp="1"/>
           </p:cNvSpPr>
@@ -8483,7 +8483,7 @@
       </p:sp>
       <p:sp>
         <p:nvSpPr>
-          <p:cNvPr id="1095" name="Slide Number Placeholder"/>
+          <p:cNvPr id="1102" name="Slide Number Placeholder"/>
           <p:cNvSpPr>
             <a:spLocks noGrp="1"/>
           </p:cNvSpPr>
@@ -8870,7 +8870,7 @@
       </p:sp>
       <p:sp>
         <p:nvSpPr>
-          <p:cNvPr id="1098" name="Slide Number Placeholder"/>
+          <p:cNvPr id="1105" name="Slide Number Placeholder"/>
           <p:cNvSpPr>
             <a:spLocks noGrp="1"/>
           </p:cNvSpPr>
@@ -10137,7 +10137,7 @@
       </p:sp>
       <p:sp>
         <p:nvSpPr>
-          <p:cNvPr id="1047" name="Slide Number Placeholder"/>
+          <p:cNvPr id="1054" name="Slide Number Placeholder"/>
           <p:cNvSpPr>
             <a:spLocks noGrp="1"/>
           </p:cNvSpPr>
@@ -11355,7 +11355,7 @@
       </p:sp>
       <p:sp>
         <p:nvSpPr>
-          <p:cNvPr id="1101" name="Slide Number Placeholder"/>
+          <p:cNvPr id="1108" name="Slide Number Placeholder"/>
           <p:cNvSpPr>
             <a:spLocks noGrp="1"/>
           </p:cNvSpPr>
@@ -12983,7 +12983,7 @@
       </p:sp>
       <p:sp>
         <p:nvSpPr>
-          <p:cNvPr id="1104" name="Slide Number Placeholder"/>
+          <p:cNvPr id="1111" name="Slide Number Placeholder"/>
           <p:cNvSpPr>
             <a:spLocks noGrp="1"/>
           </p:cNvSpPr>
@@ -13429,7 +13429,7 @@
       </p:graphicFrame>
       <p:sp>
         <p:nvSpPr>
-          <p:cNvPr id="1107" name="Slide Number Placeholder"/>
+          <p:cNvPr id="1114" name="Slide Number Placeholder"/>
           <p:cNvSpPr>
             <a:spLocks noGrp="1"/>
           </p:cNvSpPr>
@@ -14117,7 +14117,7 @@
       </p:sp>
       <p:sp>
         <p:nvSpPr>
-          <p:cNvPr id="1110" name="Slide Number Placeholder"/>
+          <p:cNvPr id="1117" name="Slide Number Placeholder"/>
           <p:cNvSpPr>
             <a:spLocks noGrp="1"/>
           </p:cNvSpPr>
@@ -14255,7 +14255,7 @@
                   <a:srgbClr val="12384D"/>
                 </a:solidFill>
               </a:rPr>
-              <a:t>A1. Does the basic flow match how DBGI works?</a:t>
+              <a:t>A1. Is this the process DBGI wants?</a:t>
             </a:r>
             <a:endParaRPr sz="2200" b="1">
               <a:solidFill>
@@ -14392,7 +14392,7 @@
         <p:spPr>
           <a:xfrm>
             <a:off x="762000" y="1701800"/>
-            <a:ext cx="5334000" cy="863600"/>
+            <a:ext cx="5334000" cy="1371600"/>
           </a:xfrm>
           <a:prstGeom prst="rect">
             <a:avLst/>
@@ -14431,7 +14431,7 @@
                   <a:srgbClr val="1E2B3C"/>
                 </a:solidFill>
               </a:rPr>
-              <a:t>A partner registers a deal, DBGI checks it, decides who was first, then approves a special price. Is that really the process?</a:t>
+              <a:t>DBGI has no deal registration system yet; the portal will be the first. It follows this process: a partner registers a deal, DBGI checks it, decides who was first, then approves a special price. Is that the process DBGI wants partners to follow?</a:t>
             </a:r>
             <a:endParaRPr sz="1400" b="0">
               <a:solidFill>
@@ -14449,7 +14449,7 @@
         </p:nvSpPr>
         <p:spPr>
           <a:xfrm>
-            <a:off x="762000" y="2743200"/>
+            <a:off x="762000" y="3251200"/>
             <a:ext cx="5334000" cy="1016000"/>
           </a:xfrm>
           <a:prstGeom prst="roundRect">
@@ -14494,7 +14494,7 @@
         </p:nvSpPr>
         <p:spPr>
           <a:xfrm>
-            <a:off x="965200" y="2870200"/>
+            <a:off x="965200" y="3378200"/>
             <a:ext cx="4953000" cy="279400"/>
           </a:xfrm>
           <a:prstGeom prst="rect">
@@ -14552,7 +14552,7 @@
         </p:nvSpPr>
         <p:spPr>
           <a:xfrm>
-            <a:off x="965200" y="3149600"/>
+            <a:off x="965200" y="3657600"/>
             <a:ext cx="4978400" cy="558800"/>
           </a:xfrm>
           <a:prstGeom prst="rect">
@@ -14610,7 +14610,7 @@
         </p:nvSpPr>
         <p:spPr>
           <a:xfrm>
-            <a:off x="762000" y="3886200"/>
+            <a:off x="762000" y="4394200"/>
             <a:ext cx="5334000" cy="584200"/>
           </a:xfrm>
           <a:prstGeom prst="rect">
@@ -14768,7 +14768,7 @@
                   <a:srgbClr val="12384D"/>
                 </a:solidFill>
               </a:rPr>
-              <a:t>What happens today when a partner tells DBGI about a government deal? Where does the portal differ from that?</a:t>
+              <a:t>Is anything in this process wrong or missing for DBGI? What would you change?</a:t>
             </a:r>
             <a:endParaRPr sz="1400" b="0">
               <a:solidFill>
@@ -15272,7 +15272,7 @@
       </p:sp>
       <p:sp>
         <p:nvSpPr>
-          <p:cNvPr id="1113" name="Slide Number Placeholder"/>
+          <p:cNvPr id="1120" name="Slide Number Placeholder"/>
           <p:cNvSpPr>
             <a:spLocks noGrp="1"/>
           </p:cNvSpPr>
@@ -15410,7 +15410,7 @@
                   <a:srgbClr val="12384D"/>
                 </a:solidFill>
               </a:rPr>
-              <a:t>A2. How is this done today, without the portal?</a:t>
+              <a:t>A2. What about deals partners already told DBGI about?</a:t>
             </a:r>
             <a:endParaRPr sz="2200" b="1">
               <a:solidFill>
@@ -15547,7 +15547,7 @@
         <p:spPr>
           <a:xfrm>
             <a:off x="762000" y="1701800"/>
-            <a:ext cx="5334000" cy="863600"/>
+            <a:ext cx="5334000" cy="1117600"/>
           </a:xfrm>
           <a:prstGeom prst="rect">
             <a:avLst/>
@@ -15586,7 +15586,7 @@
                   <a:srgbClr val="1E2B3C"/>
                 </a:solidFill>
               </a:rPr>
-              <a:t>Spreadsheets, email, Viber, phone? Knowing this tells us what the portal must replace and what people will compare it to.</a:t>
+              <a:t>Before the portal goes live, partners may already have told DBGI about deals by email, phone, or chat, or been promised a special price. When the portal starts, do those deals keep their place in line?</a:t>
             </a:r>
             <a:endParaRPr sz="1400" b="0">
               <a:solidFill>
@@ -15604,8 +15604,8 @@
         </p:nvSpPr>
         <p:spPr>
           <a:xfrm>
-            <a:off x="762000" y="2743200"/>
-            <a:ext cx="5334000" cy="787400"/>
+            <a:off x="762000" y="2997200"/>
+            <a:ext cx="5334000" cy="1473200"/>
           </a:xfrm>
           <a:prstGeom prst="roundRect">
             <a:avLst/>
@@ -15649,7 +15649,7 @@
         </p:nvSpPr>
         <p:spPr>
           <a:xfrm>
-            <a:off x="965200" y="2870200"/>
+            <a:off x="965200" y="3124200"/>
             <a:ext cx="4953000" cy="279400"/>
           </a:xfrm>
           <a:prstGeom prst="rect">
@@ -15707,8 +15707,8 @@
         </p:nvSpPr>
         <p:spPr>
           <a:xfrm>
-            <a:off x="965200" y="3149600"/>
-            <a:ext cx="4978400" cy="330200"/>
+            <a:off x="965200" y="3403600"/>
+            <a:ext cx="4978400" cy="1016000"/>
           </a:xfrm>
           <a:prstGeom prst="rect">
             <a:avLst/>
@@ -15747,7 +15747,7 @@
                   <a:srgbClr val="12384D"/>
                 </a:solidFill>
               </a:rPr>
-              <a:t>Not recorded anywhere in the project.</a:t>
+              <a:t>The portal only knows deals entered into it, and ranks them by the time they were submitted in the portal. An older deal entered after launch counts from its entry time; nobody can enter an earlier date.</a:t>
             </a:r>
             <a:endParaRPr sz="1300" b="0">
               <a:solidFill>
@@ -15765,7 +15765,7 @@
         </p:nvSpPr>
         <p:spPr>
           <a:xfrm>
-            <a:off x="762000" y="3657600"/>
+            <a:off x="762000" y="4597400"/>
             <a:ext cx="5334000" cy="584200"/>
           </a:xfrm>
           <a:prstGeom prst="rect">
@@ -15805,7 +15805,7 @@
                   <a:srgbClr val="5B6B7A"/>
                 </a:solidFill>
               </a:rPr>
-              <a:t>Why it matters: importing existing deals, matching familiar terms and columns.</a:t>
+              <a:t>Why it matters: the launch plan, and whether the portal needs a way to enter older deals with their original date.</a:t>
             </a:r>
             <a:endParaRPr sz="1200" b="0">
               <a:solidFill>
@@ -15863,7 +15863,7 @@
                   <a:srgbClr val="1B7FA6"/>
                 </a:solidFill>
               </a:rPr>
-              <a:t>TELL US</a:t>
+              <a:t>CHOOSE ONE</a:t>
             </a:r>
             <a:endParaRPr sz="1100" b="1">
               <a:solidFill>
@@ -15882,154 +15882,495 @@
         <p:spPr>
           <a:xfrm>
             <a:off x="6477000" y="1752600"/>
-            <a:ext cx="5080000" cy="1397000"/>
+            <a:ext cx="5080000" cy="990600"/>
           </a:xfrm>
           <a:prstGeom prst="roundRect">
             <a:avLst/>
           </a:prstGeom>
           <a:solidFill>
-            <a:srgbClr val="E4EEF2"/>
+            <a:srgbClr val="FFFFFF"/>
           </a:solidFill>
-          <a:ln>
-            <a:noFill/>
-          </a:ln>
-        </p:spPr>
-        <p:style>
-          <a:lnRef idx="2">
-            <a:schemeClr val="accent1">
-              <a:shade val="50000"/>
-            </a:schemeClr>
-          </a:lnRef>
-          <a:fillRef idx="1">
-            <a:schemeClr val="accent1"/>
-          </a:fillRef>
-          <a:effectRef idx="0">
-            <a:schemeClr val="accent1"/>
-          </a:effectRef>
-          <a:fontRef idx="minor">
-            <a:schemeClr val="lt1"/>
-          </a:fontRef>
-        </p:style>
-        <p:txBody>
-          <a:bodyPr wrap="square" lIns="558800" rIns="177800" anchor="ctr">
+          <a:ln w="12700">
+            <a:solidFill>
+              <a:srgbClr val="C9D6DE"/>
+            </a:solidFill>
+          </a:ln>
+        </p:spPr>
+        <p:style>
+          <a:lnRef idx="2">
+            <a:schemeClr val="accent1">
+              <a:shade val="50000"/>
+            </a:schemeClr>
+          </a:lnRef>
+          <a:fillRef idx="1">
+            <a:schemeClr val="accent1"/>
+          </a:fillRef>
+          <a:effectRef idx="0">
+            <a:schemeClr val="accent1"/>
+          </a:effectRef>
+          <a:fontRef idx="minor">
+            <a:schemeClr val="lt1"/>
+          </a:fontRef>
+        </p:style>
+        <p:txBody>
+          <a:bodyPr anchor="ctr"/>
+          <a:lstStyle/>
+          <a:p>
+            <a:pPr algn="ctr"/>
+          </a:p>
+        </p:txBody>
+      </p:sp>
+      <p:sp>
+        <p:nvSpPr>
+          <p:cNvPr id="610" name="Oval 12"/>
+          <p:cNvSpPr/>
+          <p:nvPr/>
+        </p:nvSpPr>
+        <p:spPr>
+          <a:xfrm>
+            <a:off x="6629400" y="2057400"/>
+            <a:ext cx="381000" cy="381000"/>
+          </a:xfrm>
+          <a:prstGeom prst="ellipse">
+            <a:avLst/>
+          </a:prstGeom>
+          <a:solidFill>
+            <a:srgbClr val="1B7FA6"/>
+          </a:solidFill>
+          <a:ln>
+            <a:noFill/>
+          </a:ln>
+        </p:spPr>
+        <p:style>
+          <a:lnRef idx="2">
+            <a:schemeClr val="accent1">
+              <a:shade val="50000"/>
+            </a:schemeClr>
+          </a:lnRef>
+          <a:fillRef idx="1">
+            <a:schemeClr val="accent1"/>
+          </a:fillRef>
+          <a:effectRef idx="0">
+            <a:schemeClr val="accent1"/>
+          </a:effectRef>
+          <a:fontRef idx="minor">
+            <a:schemeClr val="lt1"/>
+          </a:fontRef>
+        </p:style>
+        <p:txBody>
+          <a:bodyPr wrap="square" anchor="ctr">
             <a:noAutofit/>
           </a:bodyPr>
           <a:lstStyle/>
           <a:p>
+            <a:pPr algn="ctr"/>
+            <a:r>
+              <a:rPr sz="1400" b="1">
+                <a:solidFill>
+                  <a:srgbClr val="FFFFFF"/>
+                </a:solidFill>
+              </a:rPr>
+              <a:t>a</a:t>
+            </a:r>
+            <a:endParaRPr sz="1400" b="1">
+              <a:solidFill>
+                <a:srgbClr val="FFFFFF"/>
+              </a:solidFill>
+            </a:endParaRPr>
+          </a:p>
+        </p:txBody>
+      </p:sp>
+      <p:sp>
+        <p:nvSpPr>
+          <p:cNvPr id="611" name="Rectangle 13"/>
+          <p:cNvSpPr/>
+          <p:nvPr/>
+        </p:nvSpPr>
+        <p:spPr>
+          <a:xfrm>
+            <a:off x="7137400" y="1803400"/>
+            <a:ext cx="4318000" cy="889000"/>
+          </a:xfrm>
+          <a:prstGeom prst="rect">
+            <a:avLst/>
+          </a:prstGeom>
+          <a:noFill/>
+          <a:ln>
+            <a:noFill/>
+          </a:ln>
+        </p:spPr>
+        <p:style>
+          <a:lnRef idx="2">
+            <a:schemeClr val="accent1">
+              <a:shade val="50000"/>
+            </a:schemeClr>
+          </a:lnRef>
+          <a:fillRef idx="1">
+            <a:schemeClr val="accent1"/>
+          </a:fillRef>
+          <a:effectRef idx="0">
+            <a:schemeClr val="accent1"/>
+          </a:effectRef>
+          <a:fontRef idx="minor">
+            <a:schemeClr val="lt1"/>
+          </a:fontRef>
+        </p:style>
+        <p:txBody>
+          <a:bodyPr wrap="square" anchor="ctr">
+            <a:noAutofit/>
+          </a:bodyPr>
+          <a:lstStyle/>
+          <a:p>
             <a:pPr algn="l"/>
             <a:r>
-              <a:rPr sz="1400" b="0">
-                <a:solidFill>
-                  <a:srgbClr val="12384D"/>
-                </a:solidFill>
-              </a:rPr>
-              <a:t>What do you use today (spreadsheet, email, chat)? If you can, attach an example from a recent deal, with partner names removed.</a:t>
-            </a:r>
-            <a:endParaRPr sz="1400" b="0">
-              <a:solidFill>
-                <a:srgbClr val="12384D"/>
-              </a:solidFill>
-            </a:endParaRPr>
-          </a:p>
-        </p:txBody>
-      </p:sp>
-      <p:sp>
-        <p:nvSpPr>
-          <p:cNvPr id="610" name="Message"/>
-          <p:cNvSpPr/>
-          <p:nvPr/>
-        </p:nvSpPr>
-        <p:spPr>
-          <a:xfrm>
-            <a:off x="6629400" y="2311400"/>
-            <a:ext cx="279400" cy="279400"/>
-          </a:xfrm>
-          <a:custGeom>
-            <a:avLst/>
-            <a:gdLst/>
-            <a:ahLst/>
-            <a:cxnLst/>
-            <a:rect l="l" t="t" r="r" b="b"/>
-            <a:pathLst>
-              <a:path w="100000" h="100000" fill="none">
-                <a:moveTo>
-                  <a:pt x="12467" y="68092"/>
-                </a:moveTo>
-                <a:cubicBezTo>
-                  <a:pt x="13079" y="69637"/>
-                  <a:pt x="13216" y="71330"/>
-                  <a:pt x="12858" y="72954"/>
-                </a:cubicBezTo>
-                <a:lnTo>
-                  <a:pt x="8421" y="86663"/>
-                </a:lnTo>
-                <a:cubicBezTo>
-                  <a:pt x="8130" y="88076"/>
-                  <a:pt x="8591" y="89539"/>
-                  <a:pt x="9640" y="90530"/>
-                </a:cubicBezTo>
-                <a:cubicBezTo>
-                  <a:pt x="10689" y="91521"/>
-                  <a:pt x="12176" y="91899"/>
-                  <a:pt x="13571" y="91529"/>
-                </a:cubicBezTo>
-                <a:lnTo>
-                  <a:pt x="27792" y="87371"/>
-                </a:lnTo>
-                <a:cubicBezTo>
-                  <a:pt x="29324" y="87067"/>
-                  <a:pt x="30910" y="87200"/>
-                  <a:pt x="32371" y="87754"/>
-                </a:cubicBezTo>
-                <a:cubicBezTo>
-                  <a:pt x="50740" y="96333"/>
-                  <a:pt x="72617" y="90445"/>
-                  <a:pt x="84199" y="73806"/>
-                </a:cubicBezTo>
-                <a:cubicBezTo>
-                  <a:pt x="95781" y="57167"/>
-                  <a:pt x="93706" y="34607"/>
-                  <a:pt x="79284" y="20359"/>
-                </a:cubicBezTo>
-                <a:cubicBezTo>
-                  <a:pt x="64861" y="6112"/>
-                  <a:pt x="42277" y="4313"/>
-                  <a:pt x="25781" y="16097"/>
-                </a:cubicBezTo>
-                <a:cubicBezTo>
-                  <a:pt x="9285" y="27882"/>
-                  <a:pt x="3665" y="49829"/>
-                  <a:pt x="12467" y="68092"/>
-                </a:cubicBezTo>
-              </a:path>
-            </a:pathLst>
-          </a:custGeom>
+              <a:rPr sz="1300" b="0">
+                <a:solidFill>
+                  <a:srgbClr val="1E2B3C"/>
+                </a:solidFill>
+              </a:rPr>
+              <a:t>Start fresh: only deals submitted in the portal count, and partners are told the launch date in advance</a:t>
+            </a:r>
+            <a:endParaRPr sz="1300" b="0">
+              <a:solidFill>
+                <a:srgbClr val="1E2B3C"/>
+              </a:solidFill>
+            </a:endParaRPr>
+          </a:p>
+        </p:txBody>
+      </p:sp>
+      <p:sp>
+        <p:nvSpPr>
+          <p:cNvPr id="612" name="Rectangle 14"/>
+          <p:cNvSpPr/>
+          <p:nvPr/>
+        </p:nvSpPr>
+        <p:spPr>
+          <a:xfrm>
+            <a:off x="6477000" y="2870200"/>
+            <a:ext cx="5080000" cy="762000"/>
+          </a:xfrm>
+          <a:prstGeom prst="roundRect">
+            <a:avLst/>
+          </a:prstGeom>
+          <a:solidFill>
+            <a:srgbClr val="FFFFFF"/>
+          </a:solidFill>
+          <a:ln w="12700">
+            <a:solidFill>
+              <a:srgbClr val="C9D6DE"/>
+            </a:solidFill>
+          </a:ln>
+        </p:spPr>
+        <p:style>
+          <a:lnRef idx="2">
+            <a:schemeClr val="accent1">
+              <a:shade val="50000"/>
+            </a:schemeClr>
+          </a:lnRef>
+          <a:fillRef idx="1">
+            <a:schemeClr val="accent1"/>
+          </a:fillRef>
+          <a:effectRef idx="0">
+            <a:schemeClr val="accent1"/>
+          </a:effectRef>
+          <a:fontRef idx="minor">
+            <a:schemeClr val="lt1"/>
+          </a:fontRef>
+        </p:style>
+        <p:txBody>
+          <a:bodyPr anchor="ctr"/>
+          <a:lstStyle/>
+          <a:p>
+            <a:pPr algn="ctr"/>
+          </a:p>
+        </p:txBody>
+      </p:sp>
+      <p:sp>
+        <p:nvSpPr>
+          <p:cNvPr id="613" name="Oval 15"/>
+          <p:cNvSpPr/>
+          <p:nvPr/>
+        </p:nvSpPr>
+        <p:spPr>
+          <a:xfrm>
+            <a:off x="6629400" y="3060700"/>
+            <a:ext cx="381000" cy="381000"/>
+          </a:xfrm>
+          <a:prstGeom prst="ellipse">
+            <a:avLst/>
+          </a:prstGeom>
+          <a:solidFill>
+            <a:srgbClr val="1B7FA6"/>
+          </a:solidFill>
+          <a:ln>
+            <a:noFill/>
+          </a:ln>
+        </p:spPr>
+        <p:style>
+          <a:lnRef idx="2">
+            <a:schemeClr val="accent1">
+              <a:shade val="50000"/>
+            </a:schemeClr>
+          </a:lnRef>
+          <a:fillRef idx="1">
+            <a:schemeClr val="accent1"/>
+          </a:fillRef>
+          <a:effectRef idx="0">
+            <a:schemeClr val="accent1"/>
+          </a:effectRef>
+          <a:fontRef idx="minor">
+            <a:schemeClr val="lt1"/>
+          </a:fontRef>
+        </p:style>
+        <p:txBody>
+          <a:bodyPr wrap="square" anchor="ctr">
+            <a:noAutofit/>
+          </a:bodyPr>
+          <a:lstStyle/>
+          <a:p>
+            <a:pPr algn="ctr"/>
+            <a:r>
+              <a:rPr sz="1400" b="1">
+                <a:solidFill>
+                  <a:srgbClr val="FFFFFF"/>
+                </a:solidFill>
+              </a:rPr>
+              <a:t>b</a:t>
+            </a:r>
+            <a:endParaRPr sz="1400" b="1">
+              <a:solidFill>
+                <a:srgbClr val="FFFFFF"/>
+              </a:solidFill>
+            </a:endParaRPr>
+          </a:p>
+        </p:txBody>
+      </p:sp>
+      <p:sp>
+        <p:nvSpPr>
+          <p:cNvPr id="614" name="Rectangle 16"/>
+          <p:cNvSpPr/>
+          <p:nvPr/>
+        </p:nvSpPr>
+        <p:spPr>
+          <a:xfrm>
+            <a:off x="7137400" y="2921000"/>
+            <a:ext cx="4318000" cy="660400"/>
+          </a:xfrm>
+          <a:prstGeom prst="rect">
+            <a:avLst/>
+          </a:prstGeom>
           <a:noFill/>
-          <a:ln w="23283" cap="rnd">
+          <a:ln>
+            <a:noFill/>
+          </a:ln>
+        </p:spPr>
+        <p:style>
+          <a:lnRef idx="2">
+            <a:schemeClr val="accent1">
+              <a:shade val="50000"/>
+            </a:schemeClr>
+          </a:lnRef>
+          <a:fillRef idx="1">
+            <a:schemeClr val="accent1"/>
+          </a:fillRef>
+          <a:effectRef idx="0">
+            <a:schemeClr val="accent1"/>
+          </a:effectRef>
+          <a:fontRef idx="minor">
+            <a:schemeClr val="lt1"/>
+          </a:fontRef>
+        </p:style>
+        <p:txBody>
+          <a:bodyPr wrap="square" anchor="ctr">
+            <a:noAutofit/>
+          </a:bodyPr>
+          <a:lstStyle/>
+          <a:p>
+            <a:pPr algn="l"/>
+            <a:r>
+              <a:rPr sz="1300" b="0">
+                <a:solidFill>
+                  <a:srgbClr val="1E2B3C"/>
+                </a:solidFill>
+              </a:rPr>
+              <a:t>DBGI enters known deals at launch, with proof of the earlier date, and ranks them first</a:t>
+            </a:r>
+            <a:endParaRPr sz="1300" b="0">
+              <a:solidFill>
+                <a:srgbClr val="1E2B3C"/>
+              </a:solidFill>
+            </a:endParaRPr>
+          </a:p>
+        </p:txBody>
+      </p:sp>
+      <p:sp>
+        <p:nvSpPr>
+          <p:cNvPr id="615" name="Rectangle 17"/>
+          <p:cNvSpPr/>
+          <p:nvPr/>
+        </p:nvSpPr>
+        <p:spPr>
+          <a:xfrm>
+            <a:off x="6477000" y="3759200"/>
+            <a:ext cx="5080000" cy="990600"/>
+          </a:xfrm>
+          <a:prstGeom prst="roundRect">
+            <a:avLst/>
+          </a:prstGeom>
+          <a:solidFill>
+            <a:srgbClr val="FFFFFF"/>
+          </a:solidFill>
+          <a:ln w="12700">
             <a:solidFill>
-              <a:srgbClr val="12384D"/>
+              <a:srgbClr val="C9D6DE"/>
             </a:solidFill>
-            <a:round/>
-          </a:ln>
-        </p:spPr>
-        <p:style>
-          <a:lnRef idx="1">
-            <a:schemeClr val="tx1"/>
-          </a:lnRef>
-          <a:fillRef idx="0">
-            <a:schemeClr val="tx1"/>
-          </a:fillRef>
-          <a:effectRef idx="0">
-            <a:schemeClr val="tx1"/>
-          </a:effectRef>
-          <a:fontRef idx="minor">
-            <a:schemeClr val="tx1"/>
-          </a:fontRef>
-        </p:style>
-      </p:sp>
-      <p:sp>
-        <p:nvSpPr>
-          <p:cNvPr id="611" name="Rectangle 13"/>
+          </a:ln>
+        </p:spPr>
+        <p:style>
+          <a:lnRef idx="2">
+            <a:schemeClr val="accent1">
+              <a:shade val="50000"/>
+            </a:schemeClr>
+          </a:lnRef>
+          <a:fillRef idx="1">
+            <a:schemeClr val="accent1"/>
+          </a:fillRef>
+          <a:effectRef idx="0">
+            <a:schemeClr val="accent1"/>
+          </a:effectRef>
+          <a:fontRef idx="minor">
+            <a:schemeClr val="lt1"/>
+          </a:fontRef>
+        </p:style>
+        <p:txBody>
+          <a:bodyPr anchor="ctr"/>
+          <a:lstStyle/>
+          <a:p>
+            <a:pPr algn="ctr"/>
+          </a:p>
+        </p:txBody>
+      </p:sp>
+      <p:sp>
+        <p:nvSpPr>
+          <p:cNvPr id="616" name="Oval 18"/>
+          <p:cNvSpPr/>
+          <p:nvPr/>
+        </p:nvSpPr>
+        <p:spPr>
+          <a:xfrm>
+            <a:off x="6629400" y="4064000"/>
+            <a:ext cx="381000" cy="381000"/>
+          </a:xfrm>
+          <a:prstGeom prst="ellipse">
+            <a:avLst/>
+          </a:prstGeom>
+          <a:solidFill>
+            <a:srgbClr val="1B7FA6"/>
+          </a:solidFill>
+          <a:ln>
+            <a:noFill/>
+          </a:ln>
+        </p:spPr>
+        <p:style>
+          <a:lnRef idx="2">
+            <a:schemeClr val="accent1">
+              <a:shade val="50000"/>
+            </a:schemeClr>
+          </a:lnRef>
+          <a:fillRef idx="1">
+            <a:schemeClr val="accent1"/>
+          </a:fillRef>
+          <a:effectRef idx="0">
+            <a:schemeClr val="accent1"/>
+          </a:effectRef>
+          <a:fontRef idx="minor">
+            <a:schemeClr val="lt1"/>
+          </a:fontRef>
+        </p:style>
+        <p:txBody>
+          <a:bodyPr wrap="square" anchor="ctr">
+            <a:noAutofit/>
+          </a:bodyPr>
+          <a:lstStyle/>
+          <a:p>
+            <a:pPr algn="ctr"/>
+            <a:r>
+              <a:rPr sz="1400" b="1">
+                <a:solidFill>
+                  <a:srgbClr val="FFFFFF"/>
+                </a:solidFill>
+              </a:rPr>
+              <a:t>c</a:t>
+            </a:r>
+            <a:endParaRPr sz="1400" b="1">
+              <a:solidFill>
+                <a:srgbClr val="FFFFFF"/>
+              </a:solidFill>
+            </a:endParaRPr>
+          </a:p>
+        </p:txBody>
+      </p:sp>
+      <p:sp>
+        <p:nvSpPr>
+          <p:cNvPr id="617" name="Rectangle 19"/>
+          <p:cNvSpPr/>
+          <p:nvPr/>
+        </p:nvSpPr>
+        <p:spPr>
+          <a:xfrm>
+            <a:off x="7137400" y="3810000"/>
+            <a:ext cx="4318000" cy="889000"/>
+          </a:xfrm>
+          <a:prstGeom prst="rect">
+            <a:avLst/>
+          </a:prstGeom>
+          <a:noFill/>
+          <a:ln>
+            <a:noFill/>
+          </a:ln>
+        </p:spPr>
+        <p:style>
+          <a:lnRef idx="2">
+            <a:schemeClr val="accent1">
+              <a:shade val="50000"/>
+            </a:schemeClr>
+          </a:lnRef>
+          <a:fillRef idx="1">
+            <a:schemeClr val="accent1"/>
+          </a:fillRef>
+          <a:effectRef idx="0">
+            <a:schemeClr val="accent1"/>
+          </a:effectRef>
+          <a:fontRef idx="minor">
+            <a:schemeClr val="lt1"/>
+          </a:fontRef>
+        </p:style>
+        <p:txBody>
+          <a:bodyPr wrap="square" anchor="ctr">
+            <a:noAutofit/>
+          </a:bodyPr>
+          <a:lstStyle/>
+          <a:p>
+            <a:pPr algn="l"/>
+            <a:r>
+              <a:rPr sz="1300" b="0">
+                <a:solidFill>
+                  <a:srgbClr val="1E2B3C"/>
+                </a:solidFill>
+              </a:rPr>
+              <a:t>Partners get a short window (for example two weeks) to register existing deals, which DBGI reviews case by case</a:t>
+            </a:r>
+            <a:endParaRPr sz="1300" b="0">
+              <a:solidFill>
+                <a:srgbClr val="1E2B3C"/>
+              </a:solidFill>
+            </a:endParaRPr>
+          </a:p>
+        </p:txBody>
+      </p:sp>
+      <p:sp>
+        <p:nvSpPr>
+          <p:cNvPr id="618" name="Rectangle 20"/>
           <p:cNvSpPr/>
           <p:nvPr/>
         </p:nvSpPr>
@@ -16074,7 +16415,7 @@
       </p:sp>
       <p:sp>
         <p:nvSpPr>
-          <p:cNvPr id="612" name="Document"/>
+          <p:cNvPr id="619" name="Document"/>
           <p:cNvSpPr/>
           <p:nvPr/>
         </p:nvSpPr>
@@ -16192,7 +16533,7 @@
       </p:sp>
       <p:sp>
         <p:nvSpPr>
-          <p:cNvPr id="613" name="Rectangle 15"/>
+          <p:cNvPr id="620" name="Rectangle 22"/>
           <p:cNvSpPr/>
           <p:nvPr/>
         </p:nvSpPr>
@@ -16238,7 +16579,7 @@
                   <a:srgbClr val="12384D"/>
                 </a:solidFill>
               </a:rPr>
-              <a:t>Answer form, row A2:  write your answer in Notes</a:t>
+              <a:t>Answer form, row A2:  pick a choice, keep today, or write your own</a:t>
             </a:r>
             <a:endParaRPr sz="1400" b="1">
               <a:solidFill>
@@ -16250,7 +16591,7 @@
       </p:sp>
       <p:sp>
         <p:nvSpPr>
-          <p:cNvPr id="1116" name="Slide Number Placeholder"/>
+          <p:cNvPr id="1123" name="Slide Number Placeholder"/>
           <p:cNvSpPr>
             <a:spLocks noGrp="1"/>
           </p:cNvSpPr>
@@ -16297,7 +16638,7 @@
       </p:grpSpPr>
       <p:sp>
         <p:nvSpPr>
-          <p:cNvPr id="615" name="Rectangle 1"/>
+          <p:cNvPr id="622" name="Rectangle 1"/>
           <p:cNvSpPr/>
           <p:nvPr/>
         </p:nvSpPr>
@@ -16342,7 +16683,7 @@
       </p:sp>
       <p:sp>
         <p:nvSpPr>
-          <p:cNvPr id="616" name="Rectangle 2"/>
+          <p:cNvPr id="623" name="Rectangle 2"/>
           <p:cNvSpPr/>
           <p:nvPr/>
         </p:nvSpPr>
@@ -16400,7 +16741,7 @@
       </p:sp>
       <p:sp>
         <p:nvSpPr>
-          <p:cNvPr id="617" name="Rectangle 3"/>
+          <p:cNvPr id="624" name="Rectangle 3"/>
           <p:cNvSpPr/>
           <p:nvPr/>
         </p:nvSpPr>
@@ -16460,7 +16801,7 @@
       </p:sp>
       <p:sp>
         <p:nvSpPr>
-          <p:cNvPr id="618" name="Rectangle 4"/>
+          <p:cNvPr id="625" name="Rectangle 4"/>
           <p:cNvSpPr/>
           <p:nvPr/>
         </p:nvSpPr>
@@ -16518,7 +16859,7 @@
       </p:sp>
       <p:sp>
         <p:nvSpPr>
-          <p:cNvPr id="619" name="Rectangle 5"/>
+          <p:cNvPr id="626" name="Rectangle 5"/>
           <p:cNvSpPr/>
           <p:nvPr/>
         </p:nvSpPr>
@@ -16576,7 +16917,7 @@
       </p:sp>
       <p:sp>
         <p:nvSpPr>
-          <p:cNvPr id="620" name="Rectangle 6"/>
+          <p:cNvPr id="627" name="Rectangle 6"/>
           <p:cNvSpPr/>
           <p:nvPr/>
         </p:nvSpPr>
@@ -16621,7 +16962,7 @@
       </p:sp>
       <p:sp>
         <p:nvSpPr>
-          <p:cNvPr id="621" name="Rectangle 7"/>
+          <p:cNvPr id="628" name="Rectangle 7"/>
           <p:cNvSpPr/>
           <p:nvPr/>
         </p:nvSpPr>
@@ -16679,7 +17020,7 @@
       </p:sp>
       <p:sp>
         <p:nvSpPr>
-          <p:cNvPr id="622" name="Rectangle 8"/>
+          <p:cNvPr id="629" name="Rectangle 8"/>
           <p:cNvSpPr/>
           <p:nvPr/>
         </p:nvSpPr>
@@ -16737,7 +17078,7 @@
       </p:sp>
       <p:sp>
         <p:nvSpPr>
-          <p:cNvPr id="623" name="Rectangle 9"/>
+          <p:cNvPr id="630" name="Rectangle 9"/>
           <p:cNvSpPr/>
           <p:nvPr/>
         </p:nvSpPr>
@@ -16795,7 +17136,7 @@
       </p:sp>
       <p:sp>
         <p:nvSpPr>
-          <p:cNvPr id="624" name="Rectangle 10"/>
+          <p:cNvPr id="631" name="Rectangle 10"/>
           <p:cNvSpPr/>
           <p:nvPr/>
         </p:nvSpPr>
@@ -16853,7 +17194,7 @@
       </p:sp>
       <p:sp>
         <p:nvSpPr>
-          <p:cNvPr id="625" name="Rectangle 11"/>
+          <p:cNvPr id="632" name="Rectangle 11"/>
           <p:cNvSpPr/>
           <p:nvPr/>
         </p:nvSpPr>
@@ -16900,7 +17241,7 @@
       </p:sp>
       <p:sp>
         <p:nvSpPr>
-          <p:cNvPr id="626" name="Oval 12"/>
+          <p:cNvPr id="633" name="Oval 12"/>
           <p:cNvSpPr/>
           <p:nvPr/>
         </p:nvSpPr>
@@ -16960,7 +17301,7 @@
       </p:sp>
       <p:sp>
         <p:nvSpPr>
-          <p:cNvPr id="627" name="Rectangle 13"/>
+          <p:cNvPr id="634" name="Rectangle 13"/>
           <p:cNvSpPr/>
           <p:nvPr/>
         </p:nvSpPr>
@@ -17018,7 +17359,7 @@
       </p:sp>
       <p:sp>
         <p:nvSpPr>
-          <p:cNvPr id="628" name="Rectangle 14"/>
+          <p:cNvPr id="635" name="Rectangle 14"/>
           <p:cNvSpPr/>
           <p:nvPr/>
         </p:nvSpPr>
@@ -17065,7 +17406,7 @@
       </p:sp>
       <p:sp>
         <p:nvSpPr>
-          <p:cNvPr id="629" name="Oval 15"/>
+          <p:cNvPr id="636" name="Oval 15"/>
           <p:cNvSpPr/>
           <p:nvPr/>
         </p:nvSpPr>
@@ -17125,7 +17466,7 @@
       </p:sp>
       <p:sp>
         <p:nvSpPr>
-          <p:cNvPr id="630" name="Rectangle 16"/>
+          <p:cNvPr id="637" name="Rectangle 16"/>
           <p:cNvSpPr/>
           <p:nvPr/>
         </p:nvSpPr>
@@ -17183,7 +17524,7 @@
       </p:sp>
       <p:sp>
         <p:nvSpPr>
-          <p:cNvPr id="631" name="Picture"/>
+          <p:cNvPr id="638" name="Picture"/>
           <p:cNvSpPr/>
           <p:nvPr/>
         </p:nvSpPr>
@@ -17302,7 +17643,7 @@
       </p:sp>
       <p:sp>
         <p:nvSpPr>
-          <p:cNvPr id="632" name="Rectangle 18"/>
+          <p:cNvPr id="639" name="Rectangle 18"/>
           <p:cNvSpPr/>
           <p:nvPr/>
         </p:nvSpPr>
@@ -17360,7 +17701,7 @@
       </p:sp>
       <p:sp>
         <p:nvSpPr>
-          <p:cNvPr id="633" name="Rectangle 19"/>
+          <p:cNvPr id="640" name="Rectangle 19"/>
           <p:cNvSpPr/>
           <p:nvPr/>
         </p:nvSpPr>
@@ -17405,7 +17746,7 @@
       </p:sp>
       <p:sp>
         <p:nvSpPr>
-          <p:cNvPr id="634" name="Document"/>
+          <p:cNvPr id="641" name="Document"/>
           <p:cNvSpPr/>
           <p:nvPr/>
         </p:nvSpPr>
@@ -17523,7 +17864,7 @@
       </p:sp>
       <p:sp>
         <p:nvSpPr>
-          <p:cNvPr id="635" name="Rectangle 21"/>
+          <p:cNvPr id="642" name="Rectangle 21"/>
           <p:cNvSpPr/>
           <p:nvPr/>
         </p:nvSpPr>
@@ -17581,7 +17922,7 @@
       </p:sp>
       <p:sp>
         <p:nvSpPr>
-          <p:cNvPr id="1119" name="Slide Number Placeholder"/>
+          <p:cNvPr id="1126" name="Slide Number Placeholder"/>
           <p:cNvSpPr>
             <a:spLocks noGrp="1"/>
           </p:cNvSpPr>
@@ -17628,7 +17969,7 @@
       </p:grpSpPr>
       <p:sp>
         <p:nvSpPr>
-          <p:cNvPr id="637" name="Rectangle 1"/>
+          <p:cNvPr id="644" name="Rectangle 1"/>
           <p:cNvSpPr/>
           <p:nvPr/>
         </p:nvSpPr>
@@ -17673,7 +18014,7 @@
       </p:sp>
       <p:sp>
         <p:nvSpPr>
-          <p:cNvPr id="638" name="Rectangle 2"/>
+          <p:cNvPr id="645" name="Rectangle 2"/>
           <p:cNvSpPr/>
           <p:nvPr/>
         </p:nvSpPr>
@@ -17731,7 +18072,7 @@
       </p:sp>
       <p:sp>
         <p:nvSpPr>
-          <p:cNvPr id="639" name="Rectangle 3"/>
+          <p:cNvPr id="646" name="Rectangle 3"/>
           <p:cNvSpPr/>
           <p:nvPr/>
         </p:nvSpPr>
@@ -17791,7 +18132,7 @@
       </p:sp>
       <p:sp>
         <p:nvSpPr>
-          <p:cNvPr id="640" name="Rectangle 4"/>
+          <p:cNvPr id="647" name="Rectangle 4"/>
           <p:cNvSpPr/>
           <p:nvPr/>
         </p:nvSpPr>
@@ -17849,7 +18190,7 @@
       </p:sp>
       <p:sp>
         <p:nvSpPr>
-          <p:cNvPr id="641" name="Rectangle 5"/>
+          <p:cNvPr id="648" name="Rectangle 5"/>
           <p:cNvSpPr/>
           <p:nvPr/>
         </p:nvSpPr>
@@ -17907,7 +18248,7 @@
       </p:sp>
       <p:sp>
         <p:nvSpPr>
-          <p:cNvPr id="642" name="Rectangle 6"/>
+          <p:cNvPr id="649" name="Rectangle 6"/>
           <p:cNvSpPr/>
           <p:nvPr/>
         </p:nvSpPr>
@@ -17952,7 +18293,7 @@
       </p:sp>
       <p:sp>
         <p:nvSpPr>
-          <p:cNvPr id="643" name="Rectangle 7"/>
+          <p:cNvPr id="650" name="Rectangle 7"/>
           <p:cNvSpPr/>
           <p:nvPr/>
         </p:nvSpPr>
@@ -18010,7 +18351,7 @@
       </p:sp>
       <p:sp>
         <p:nvSpPr>
-          <p:cNvPr id="644" name="Rectangle 8"/>
+          <p:cNvPr id="651" name="Rectangle 8"/>
           <p:cNvSpPr/>
           <p:nvPr/>
         </p:nvSpPr>
@@ -18068,7 +18409,7 @@
       </p:sp>
       <p:sp>
         <p:nvSpPr>
-          <p:cNvPr id="645" name="Rectangle 9"/>
+          <p:cNvPr id="652" name="Rectangle 9"/>
           <p:cNvSpPr/>
           <p:nvPr/>
         </p:nvSpPr>
@@ -18126,7 +18467,7 @@
       </p:sp>
       <p:sp>
         <p:nvSpPr>
-          <p:cNvPr id="646" name="Rectangle 10"/>
+          <p:cNvPr id="653" name="Rectangle 10"/>
           <p:cNvSpPr/>
           <p:nvPr/>
         </p:nvSpPr>
@@ -18184,7 +18525,7 @@
       </p:sp>
       <p:sp>
         <p:nvSpPr>
-          <p:cNvPr id="647" name="Rectangle 11"/>
+          <p:cNvPr id="654" name="Rectangle 11"/>
           <p:cNvSpPr/>
           <p:nvPr/>
         </p:nvSpPr>
@@ -18231,7 +18572,7 @@
       </p:sp>
       <p:sp>
         <p:nvSpPr>
-          <p:cNvPr id="648" name="Oval 12"/>
+          <p:cNvPr id="655" name="Oval 12"/>
           <p:cNvSpPr/>
           <p:nvPr/>
         </p:nvSpPr>
@@ -18291,7 +18632,7 @@
       </p:sp>
       <p:sp>
         <p:nvSpPr>
-          <p:cNvPr id="649" name="Rectangle 13"/>
+          <p:cNvPr id="656" name="Rectangle 13"/>
           <p:cNvSpPr/>
           <p:nvPr/>
         </p:nvSpPr>
@@ -18349,7 +18690,7 @@
       </p:sp>
       <p:sp>
         <p:nvSpPr>
-          <p:cNvPr id="650" name="Rectangle 14"/>
+          <p:cNvPr id="657" name="Rectangle 14"/>
           <p:cNvSpPr/>
           <p:nvPr/>
         </p:nvSpPr>
@@ -18396,7 +18737,7 @@
       </p:sp>
       <p:sp>
         <p:nvSpPr>
-          <p:cNvPr id="651" name="Oval 15"/>
+          <p:cNvPr id="658" name="Oval 15"/>
           <p:cNvSpPr/>
           <p:nvPr/>
         </p:nvSpPr>
@@ -18456,7 +18797,7 @@
       </p:sp>
       <p:sp>
         <p:nvSpPr>
-          <p:cNvPr id="652" name="Rectangle 16"/>
+          <p:cNvPr id="659" name="Rectangle 16"/>
           <p:cNvSpPr/>
           <p:nvPr/>
         </p:nvSpPr>
@@ -18514,7 +18855,7 @@
       </p:sp>
       <p:sp>
         <p:nvSpPr>
-          <p:cNvPr id="653" name="Rectangle 17"/>
+          <p:cNvPr id="660" name="Rectangle 17"/>
           <p:cNvSpPr/>
           <p:nvPr/>
         </p:nvSpPr>
@@ -18561,7 +18902,7 @@
       </p:sp>
       <p:sp>
         <p:nvSpPr>
-          <p:cNvPr id="654" name="Oval 18"/>
+          <p:cNvPr id="661" name="Oval 18"/>
           <p:cNvSpPr/>
           <p:nvPr/>
         </p:nvSpPr>
@@ -18621,7 +18962,7 @@
       </p:sp>
       <p:sp>
         <p:nvSpPr>
-          <p:cNvPr id="655" name="Rectangle 19"/>
+          <p:cNvPr id="662" name="Rectangle 19"/>
           <p:cNvSpPr/>
           <p:nvPr/>
         </p:nvSpPr>
@@ -18679,7 +19020,7 @@
       </p:sp>
       <p:sp>
         <p:nvSpPr>
-          <p:cNvPr id="656" name="Rectangle 20"/>
+          <p:cNvPr id="663" name="Rectangle 20"/>
           <p:cNvSpPr/>
           <p:nvPr/>
         </p:nvSpPr>
@@ -18724,7 +19065,7 @@
       </p:sp>
       <p:sp>
         <p:nvSpPr>
-          <p:cNvPr id="657" name="Document"/>
+          <p:cNvPr id="664" name="Document"/>
           <p:cNvSpPr/>
           <p:nvPr/>
         </p:nvSpPr>
@@ -18842,7 +19183,7 @@
       </p:sp>
       <p:sp>
         <p:nvSpPr>
-          <p:cNvPr id="658" name="Rectangle 22"/>
+          <p:cNvPr id="665" name="Rectangle 22"/>
           <p:cNvSpPr/>
           <p:nvPr/>
         </p:nvSpPr>
@@ -18900,7 +19241,7 @@
       </p:sp>
       <p:sp>
         <p:nvSpPr>
-          <p:cNvPr id="1122" name="Slide Number Placeholder"/>
+          <p:cNvPr id="1129" name="Slide Number Placeholder"/>
           <p:cNvSpPr>
             <a:spLocks noGrp="1"/>
           </p:cNvSpPr>
@@ -18947,7 +19288,7 @@
       </p:grpSpPr>
       <p:sp>
         <p:nvSpPr>
-          <p:cNvPr id="660" name="Rectangle 1"/>
+          <p:cNvPr id="667" name="Rectangle 1"/>
           <p:cNvSpPr/>
           <p:nvPr/>
         </p:nvSpPr>
@@ -18992,7 +19333,7 @@
       </p:sp>
       <p:sp>
         <p:nvSpPr>
-          <p:cNvPr id="661" name="Rectangle 2"/>
+          <p:cNvPr id="668" name="Rectangle 2"/>
           <p:cNvSpPr/>
           <p:nvPr/>
         </p:nvSpPr>
@@ -19050,7 +19391,7 @@
       </p:sp>
       <p:sp>
         <p:nvSpPr>
-          <p:cNvPr id="662" name="Rectangle 3"/>
+          <p:cNvPr id="669" name="Rectangle 3"/>
           <p:cNvSpPr/>
           <p:nvPr/>
         </p:nvSpPr>
@@ -19110,7 +19451,7 @@
       </p:sp>
       <p:sp>
         <p:nvSpPr>
-          <p:cNvPr id="663" name="Rectangle 4"/>
+          <p:cNvPr id="670" name="Rectangle 4"/>
           <p:cNvSpPr/>
           <p:nvPr/>
         </p:nvSpPr>
@@ -19168,7 +19509,7 @@
       </p:sp>
       <p:sp>
         <p:nvSpPr>
-          <p:cNvPr id="664" name="Rectangle 5"/>
+          <p:cNvPr id="671" name="Rectangle 5"/>
           <p:cNvSpPr/>
           <p:nvPr/>
         </p:nvSpPr>
@@ -19226,7 +19567,7 @@
       </p:sp>
       <p:sp>
         <p:nvSpPr>
-          <p:cNvPr id="665" name="Rectangle 6"/>
+          <p:cNvPr id="672" name="Rectangle 6"/>
           <p:cNvSpPr/>
           <p:nvPr/>
         </p:nvSpPr>
@@ -19271,7 +19612,7 @@
       </p:sp>
       <p:sp>
         <p:nvSpPr>
-          <p:cNvPr id="666" name="Rectangle 7"/>
+          <p:cNvPr id="673" name="Rectangle 7"/>
           <p:cNvSpPr/>
           <p:nvPr/>
         </p:nvSpPr>
@@ -19329,7 +19670,7 @@
       </p:sp>
       <p:sp>
         <p:nvSpPr>
-          <p:cNvPr id="667" name="Rectangle 8"/>
+          <p:cNvPr id="674" name="Rectangle 8"/>
           <p:cNvSpPr/>
           <p:nvPr/>
         </p:nvSpPr>
@@ -19387,7 +19728,7 @@
       </p:sp>
       <p:sp>
         <p:nvSpPr>
-          <p:cNvPr id="668" name="Rectangle 9"/>
+          <p:cNvPr id="675" name="Rectangle 9"/>
           <p:cNvSpPr/>
           <p:nvPr/>
         </p:nvSpPr>
@@ -19445,7 +19786,7 @@
       </p:sp>
       <p:sp>
         <p:nvSpPr>
-          <p:cNvPr id="669" name="Rectangle 10"/>
+          <p:cNvPr id="676" name="Rectangle 10"/>
           <p:cNvSpPr/>
           <p:nvPr/>
         </p:nvSpPr>
@@ -19503,7 +19844,7 @@
       </p:sp>
       <p:sp>
         <p:nvSpPr>
-          <p:cNvPr id="670" name="Rectangle 11"/>
+          <p:cNvPr id="677" name="Rectangle 11"/>
           <p:cNvSpPr/>
           <p:nvPr/>
         </p:nvSpPr>
@@ -19551,7 +19892,7 @@
                   <a:srgbClr val="12384D"/>
                 </a:solidFill>
               </a:rPr>
-              <a:t>Would a partner understand these labels? What words do you use for them today?</a:t>
+              <a:t>Would a partner understand these labels? Which words would partners and DBGI staff expect instead?</a:t>
             </a:r>
             <a:endParaRPr sz="1400" b="0">
               <a:solidFill>
@@ -19563,7 +19904,7 @@
       </p:sp>
       <p:sp>
         <p:nvSpPr>
-          <p:cNvPr id="671" name="Message"/>
+          <p:cNvPr id="678" name="Message"/>
           <p:cNvSpPr/>
           <p:nvPr/>
         </p:nvSpPr>
@@ -19657,7 +19998,7 @@
       </p:sp>
       <p:sp>
         <p:nvSpPr>
-          <p:cNvPr id="672" name="Picture"/>
+          <p:cNvPr id="679" name="Picture"/>
           <p:cNvSpPr/>
           <p:nvPr/>
         </p:nvSpPr>
@@ -19776,7 +20117,7 @@
       </p:sp>
       <p:sp>
         <p:nvSpPr>
-          <p:cNvPr id="673" name="Rectangle 14"/>
+          <p:cNvPr id="680" name="Rectangle 14"/>
           <p:cNvSpPr/>
           <p:nvPr/>
         </p:nvSpPr>
@@ -19834,7 +20175,7 @@
       </p:sp>
       <p:sp>
         <p:nvSpPr>
-          <p:cNvPr id="674" name="Rectangle 15"/>
+          <p:cNvPr id="681" name="Rectangle 15"/>
           <p:cNvSpPr/>
           <p:nvPr/>
         </p:nvSpPr>
@@ -19879,7 +20220,7 @@
       </p:sp>
       <p:sp>
         <p:nvSpPr>
-          <p:cNvPr id="675" name="Document"/>
+          <p:cNvPr id="682" name="Document"/>
           <p:cNvSpPr/>
           <p:nvPr/>
         </p:nvSpPr>
@@ -19997,7 +20338,7 @@
       </p:sp>
       <p:sp>
         <p:nvSpPr>
-          <p:cNvPr id="676" name="Rectangle 17"/>
+          <p:cNvPr id="683" name="Rectangle 17"/>
           <p:cNvSpPr/>
           <p:nvPr/>
         </p:nvSpPr>
@@ -20055,7 +20396,7 @@
       </p:sp>
       <p:sp>
         <p:nvSpPr>
-          <p:cNvPr id="1125" name="Slide Number Placeholder"/>
+          <p:cNvPr id="1132" name="Slide Number Placeholder"/>
           <p:cNvSpPr>
             <a:spLocks noGrp="1"/>
           </p:cNvSpPr>
@@ -20102,7 +20443,7 @@
       </p:grpSpPr>
       <p:sp>
         <p:nvSpPr>
-          <p:cNvPr id="678" name="Rectangle 1"/>
+          <p:cNvPr id="685" name="Rectangle 1"/>
           <p:cNvSpPr/>
           <p:nvPr/>
         </p:nvSpPr>
@@ -20147,7 +20488,7 @@
       </p:sp>
       <p:sp>
         <p:nvSpPr>
-          <p:cNvPr id="679" name="Rectangle 2"/>
+          <p:cNvPr id="686" name="Rectangle 2"/>
           <p:cNvSpPr/>
           <p:nvPr/>
         </p:nvSpPr>
@@ -20205,7 +20546,7 @@
       </p:sp>
       <p:sp>
         <p:nvSpPr>
-          <p:cNvPr id="680" name="Rectangle 3"/>
+          <p:cNvPr id="687" name="Rectangle 3"/>
           <p:cNvSpPr/>
           <p:nvPr/>
         </p:nvSpPr>
@@ -20265,7 +20606,7 @@
       </p:sp>
       <p:sp>
         <p:nvSpPr>
-          <p:cNvPr id="681" name="Rectangle 4"/>
+          <p:cNvPr id="688" name="Rectangle 4"/>
           <p:cNvSpPr/>
           <p:nvPr/>
         </p:nvSpPr>
@@ -20323,7 +20664,7 @@
       </p:sp>
       <p:sp>
         <p:nvSpPr>
-          <p:cNvPr id="682" name="Rectangle 5"/>
+          <p:cNvPr id="689" name="Rectangle 5"/>
           <p:cNvSpPr/>
           <p:nvPr/>
         </p:nvSpPr>
@@ -20381,7 +20722,7 @@
       </p:sp>
       <p:sp>
         <p:nvSpPr>
-          <p:cNvPr id="683" name="Rectangle 6"/>
+          <p:cNvPr id="690" name="Rectangle 6"/>
           <p:cNvSpPr/>
           <p:nvPr/>
         </p:nvSpPr>
@@ -20426,7 +20767,7 @@
       </p:sp>
       <p:sp>
         <p:nvSpPr>
-          <p:cNvPr id="684" name="Rectangle 7"/>
+          <p:cNvPr id="691" name="Rectangle 7"/>
           <p:cNvSpPr/>
           <p:nvPr/>
         </p:nvSpPr>
@@ -20484,7 +20825,7 @@
       </p:sp>
       <p:sp>
         <p:nvSpPr>
-          <p:cNvPr id="685" name="Rectangle 8"/>
+          <p:cNvPr id="692" name="Rectangle 8"/>
           <p:cNvSpPr/>
           <p:nvPr/>
         </p:nvSpPr>
@@ -20542,7 +20883,7 @@
       </p:sp>
       <p:sp>
         <p:nvSpPr>
-          <p:cNvPr id="686" name="Rectangle 9"/>
+          <p:cNvPr id="693" name="Rectangle 9"/>
           <p:cNvSpPr/>
           <p:nvPr/>
         </p:nvSpPr>
@@ -20600,7 +20941,7 @@
       </p:sp>
       <p:sp>
         <p:nvSpPr>
-          <p:cNvPr id="687" name="Rectangle 10"/>
+          <p:cNvPr id="694" name="Rectangle 10"/>
           <p:cNvSpPr/>
           <p:nvPr/>
         </p:nvSpPr>
@@ -20658,7 +20999,7 @@
       </p:sp>
       <p:sp>
         <p:nvSpPr>
-          <p:cNvPr id="688" name="Rectangle 11"/>
+          <p:cNvPr id="695" name="Rectangle 11"/>
           <p:cNvSpPr/>
           <p:nvPr/>
         </p:nvSpPr>
@@ -20705,7 +21046,7 @@
       </p:sp>
       <p:sp>
         <p:nvSpPr>
-          <p:cNvPr id="689" name="Oval 12"/>
+          <p:cNvPr id="696" name="Oval 12"/>
           <p:cNvSpPr/>
           <p:nvPr/>
         </p:nvSpPr>
@@ -20765,7 +21106,7 @@
       </p:sp>
       <p:sp>
         <p:nvSpPr>
-          <p:cNvPr id="690" name="Rectangle 13"/>
+          <p:cNvPr id="697" name="Rectangle 13"/>
           <p:cNvSpPr/>
           <p:nvPr/>
         </p:nvSpPr>
@@ -20823,7 +21164,7 @@
       </p:sp>
       <p:sp>
         <p:nvSpPr>
-          <p:cNvPr id="691" name="Rectangle 14"/>
+          <p:cNvPr id="698" name="Rectangle 14"/>
           <p:cNvSpPr/>
           <p:nvPr/>
         </p:nvSpPr>
@@ -20870,7 +21211,7 @@
       </p:sp>
       <p:sp>
         <p:nvSpPr>
-          <p:cNvPr id="692" name="Oval 15"/>
+          <p:cNvPr id="699" name="Oval 15"/>
           <p:cNvSpPr/>
           <p:nvPr/>
         </p:nvSpPr>
@@ -20930,7 +21271,7 @@
       </p:sp>
       <p:sp>
         <p:nvSpPr>
-          <p:cNvPr id="693" name="Rectangle 16"/>
+          <p:cNvPr id="700" name="Rectangle 16"/>
           <p:cNvSpPr/>
           <p:nvPr/>
         </p:nvSpPr>
@@ -20988,7 +21329,7 @@
       </p:sp>
       <p:sp>
         <p:nvSpPr>
-          <p:cNvPr id="694" name="Rectangle 17"/>
+          <p:cNvPr id="701" name="Rectangle 17"/>
           <p:cNvSpPr/>
           <p:nvPr/>
         </p:nvSpPr>
@@ -21035,7 +21376,7 @@
       </p:sp>
       <p:sp>
         <p:nvSpPr>
-          <p:cNvPr id="695" name="Oval 18"/>
+          <p:cNvPr id="702" name="Oval 18"/>
           <p:cNvSpPr/>
           <p:nvPr/>
         </p:nvSpPr>
@@ -21095,7 +21436,7 @@
       </p:sp>
       <p:sp>
         <p:nvSpPr>
-          <p:cNvPr id="696" name="Rectangle 19"/>
+          <p:cNvPr id="703" name="Rectangle 19"/>
           <p:cNvSpPr/>
           <p:nvPr/>
         </p:nvSpPr>
@@ -21153,7 +21494,7 @@
       </p:sp>
       <p:sp>
         <p:nvSpPr>
-          <p:cNvPr id="697" name="Picture"/>
+          <p:cNvPr id="704" name="Picture"/>
           <p:cNvSpPr/>
           <p:nvPr/>
         </p:nvSpPr>
@@ -21272,7 +21613,7 @@
       </p:sp>
       <p:sp>
         <p:nvSpPr>
-          <p:cNvPr id="698" name="Rectangle 21"/>
+          <p:cNvPr id="705" name="Rectangle 21"/>
           <p:cNvSpPr/>
           <p:nvPr/>
         </p:nvSpPr>
@@ -21330,7 +21671,7 @@
       </p:sp>
       <p:sp>
         <p:nvSpPr>
-          <p:cNvPr id="699" name="Rectangle 22"/>
+          <p:cNvPr id="706" name="Rectangle 22"/>
           <p:cNvSpPr/>
           <p:nvPr/>
         </p:nvSpPr>
@@ -21375,7 +21716,7 @@
       </p:sp>
       <p:sp>
         <p:nvSpPr>
-          <p:cNvPr id="700" name="Document"/>
+          <p:cNvPr id="707" name="Document"/>
           <p:cNvSpPr/>
           <p:nvPr/>
         </p:nvSpPr>
@@ -21493,7 +21834,7 @@
       </p:sp>
       <p:sp>
         <p:nvSpPr>
-          <p:cNvPr id="701" name="Rectangle 24"/>
+          <p:cNvPr id="708" name="Rectangle 24"/>
           <p:cNvSpPr/>
           <p:nvPr/>
         </p:nvSpPr>
@@ -21551,7 +21892,7 @@
       </p:sp>
       <p:sp>
         <p:nvSpPr>
-          <p:cNvPr id="1128" name="Slide Number Placeholder"/>
+          <p:cNvPr id="1135" name="Slide Number Placeholder"/>
           <p:cNvSpPr>
             <a:spLocks noGrp="1"/>
           </p:cNvSpPr>
@@ -23613,7 +23954,7 @@
       </p:sp>
       <p:sp>
         <p:nvSpPr>
-          <p:cNvPr id="1050" name="Slide Number Placeholder"/>
+          <p:cNvPr id="1057" name="Slide Number Placeholder"/>
           <p:cNvSpPr>
             <a:spLocks noGrp="1"/>
           </p:cNvSpPr>
@@ -23660,7 +24001,7 @@
       </p:grpSpPr>
       <p:sp>
         <p:nvSpPr>
-          <p:cNvPr id="703" name="Rectangle 1"/>
+          <p:cNvPr id="710" name="Rectangle 1"/>
           <p:cNvSpPr/>
           <p:nvPr/>
         </p:nvSpPr>
@@ -23705,7 +24046,7 @@
       </p:sp>
       <p:sp>
         <p:nvSpPr>
-          <p:cNvPr id="704" name="Rectangle 2"/>
+          <p:cNvPr id="711" name="Rectangle 2"/>
           <p:cNvSpPr/>
           <p:nvPr/>
         </p:nvSpPr>
@@ -23763,7 +24104,7 @@
       </p:sp>
       <p:sp>
         <p:nvSpPr>
-          <p:cNvPr id="705" name="Rectangle 3"/>
+          <p:cNvPr id="712" name="Rectangle 3"/>
           <p:cNvSpPr/>
           <p:nvPr/>
         </p:nvSpPr>
@@ -23823,7 +24164,7 @@
       </p:sp>
       <p:sp>
         <p:nvSpPr>
-          <p:cNvPr id="706" name="Rectangle 4"/>
+          <p:cNvPr id="713" name="Rectangle 4"/>
           <p:cNvSpPr/>
           <p:nvPr/>
         </p:nvSpPr>
@@ -23881,7 +24222,7 @@
       </p:sp>
       <p:sp>
         <p:nvSpPr>
-          <p:cNvPr id="707" name="Rectangle 5"/>
+          <p:cNvPr id="714" name="Rectangle 5"/>
           <p:cNvSpPr/>
           <p:nvPr/>
         </p:nvSpPr>
@@ -23939,7 +24280,7 @@
       </p:sp>
       <p:sp>
         <p:nvSpPr>
-          <p:cNvPr id="708" name="Rectangle 6"/>
+          <p:cNvPr id="715" name="Rectangle 6"/>
           <p:cNvSpPr/>
           <p:nvPr/>
         </p:nvSpPr>
@@ -23984,7 +24325,7 @@
       </p:sp>
       <p:sp>
         <p:nvSpPr>
-          <p:cNvPr id="709" name="Rectangle 7"/>
+          <p:cNvPr id="716" name="Rectangle 7"/>
           <p:cNvSpPr/>
           <p:nvPr/>
         </p:nvSpPr>
@@ -24042,7 +24383,7 @@
       </p:sp>
       <p:sp>
         <p:nvSpPr>
-          <p:cNvPr id="710" name="Rectangle 8"/>
+          <p:cNvPr id="717" name="Rectangle 8"/>
           <p:cNvSpPr/>
           <p:nvPr/>
         </p:nvSpPr>
@@ -24100,7 +24441,7 @@
       </p:sp>
       <p:sp>
         <p:nvSpPr>
-          <p:cNvPr id="711" name="Rectangle 9"/>
+          <p:cNvPr id="718" name="Rectangle 9"/>
           <p:cNvSpPr/>
           <p:nvPr/>
         </p:nvSpPr>
@@ -24158,7 +24499,7 @@
       </p:sp>
       <p:sp>
         <p:nvSpPr>
-          <p:cNvPr id="712" name="Rectangle 10"/>
+          <p:cNvPr id="719" name="Rectangle 10"/>
           <p:cNvSpPr/>
           <p:nvPr/>
         </p:nvSpPr>
@@ -24216,7 +24557,7 @@
       </p:sp>
       <p:sp>
         <p:nvSpPr>
-          <p:cNvPr id="713" name="Rectangle 11"/>
+          <p:cNvPr id="720" name="Rectangle 11"/>
           <p:cNvSpPr/>
           <p:nvPr/>
         </p:nvSpPr>
@@ -24263,7 +24604,7 @@
       </p:sp>
       <p:sp>
         <p:nvSpPr>
-          <p:cNvPr id="714" name="Oval 12"/>
+          <p:cNvPr id="721" name="Oval 12"/>
           <p:cNvSpPr/>
           <p:nvPr/>
         </p:nvSpPr>
@@ -24323,7 +24664,7 @@
       </p:sp>
       <p:sp>
         <p:nvSpPr>
-          <p:cNvPr id="715" name="Rectangle 13"/>
+          <p:cNvPr id="722" name="Rectangle 13"/>
           <p:cNvSpPr/>
           <p:nvPr/>
         </p:nvSpPr>
@@ -24381,7 +24722,7 @@
       </p:sp>
       <p:sp>
         <p:nvSpPr>
-          <p:cNvPr id="716" name="Rectangle 14"/>
+          <p:cNvPr id="723" name="Rectangle 14"/>
           <p:cNvSpPr/>
           <p:nvPr/>
         </p:nvSpPr>
@@ -24428,7 +24769,7 @@
       </p:sp>
       <p:sp>
         <p:nvSpPr>
-          <p:cNvPr id="717" name="Oval 15"/>
+          <p:cNvPr id="724" name="Oval 15"/>
           <p:cNvSpPr/>
           <p:nvPr/>
         </p:nvSpPr>
@@ -24488,7 +24829,7 @@
       </p:sp>
       <p:sp>
         <p:nvSpPr>
-          <p:cNvPr id="718" name="Rectangle 16"/>
+          <p:cNvPr id="725" name="Rectangle 16"/>
           <p:cNvSpPr/>
           <p:nvPr/>
         </p:nvSpPr>
@@ -24546,7 +24887,7 @@
       </p:sp>
       <p:sp>
         <p:nvSpPr>
-          <p:cNvPr id="719" name="Rectangle 17"/>
+          <p:cNvPr id="726" name="Rectangle 17"/>
           <p:cNvSpPr/>
           <p:nvPr/>
         </p:nvSpPr>
@@ -24593,7 +24934,7 @@
       </p:sp>
       <p:sp>
         <p:nvSpPr>
-          <p:cNvPr id="720" name="Oval 18"/>
+          <p:cNvPr id="727" name="Oval 18"/>
           <p:cNvSpPr/>
           <p:nvPr/>
         </p:nvSpPr>
@@ -24653,7 +24994,7 @@
       </p:sp>
       <p:sp>
         <p:nvSpPr>
-          <p:cNvPr id="721" name="Rectangle 19"/>
+          <p:cNvPr id="728" name="Rectangle 19"/>
           <p:cNvSpPr/>
           <p:nvPr/>
         </p:nvSpPr>
@@ -24711,7 +25052,7 @@
       </p:sp>
       <p:sp>
         <p:nvSpPr>
-          <p:cNvPr id="722" name="Picture"/>
+          <p:cNvPr id="729" name="Picture"/>
           <p:cNvSpPr/>
           <p:nvPr/>
         </p:nvSpPr>
@@ -24830,7 +25171,7 @@
       </p:sp>
       <p:sp>
         <p:nvSpPr>
-          <p:cNvPr id="723" name="Rectangle 21"/>
+          <p:cNvPr id="730" name="Rectangle 21"/>
           <p:cNvSpPr/>
           <p:nvPr/>
         </p:nvSpPr>
@@ -24888,7 +25229,7 @@
       </p:sp>
       <p:sp>
         <p:nvSpPr>
-          <p:cNvPr id="724" name="Rectangle 22"/>
+          <p:cNvPr id="731" name="Rectangle 22"/>
           <p:cNvSpPr/>
           <p:nvPr/>
         </p:nvSpPr>
@@ -24933,7 +25274,7 @@
       </p:sp>
       <p:sp>
         <p:nvSpPr>
-          <p:cNvPr id="725" name="Document"/>
+          <p:cNvPr id="732" name="Document"/>
           <p:cNvSpPr/>
           <p:nvPr/>
         </p:nvSpPr>
@@ -25051,7 +25392,7 @@
       </p:sp>
       <p:sp>
         <p:nvSpPr>
-          <p:cNvPr id="726" name="Rectangle 24"/>
+          <p:cNvPr id="733" name="Rectangle 24"/>
           <p:cNvSpPr/>
           <p:nvPr/>
         </p:nvSpPr>
@@ -25109,7 +25450,7 @@
       </p:sp>
       <p:sp>
         <p:nvSpPr>
-          <p:cNvPr id="1131" name="Slide Number Placeholder"/>
+          <p:cNvPr id="1138" name="Slide Number Placeholder"/>
           <p:cNvSpPr>
             <a:spLocks noGrp="1"/>
           </p:cNvSpPr>
@@ -25156,7 +25497,7 @@
       </p:grpSpPr>
       <p:sp>
         <p:nvSpPr>
-          <p:cNvPr id="728" name="Rectangle 1"/>
+          <p:cNvPr id="735" name="Rectangle 1"/>
           <p:cNvSpPr/>
           <p:nvPr/>
         </p:nvSpPr>
@@ -25201,7 +25542,7 @@
       </p:sp>
       <p:sp>
         <p:nvSpPr>
-          <p:cNvPr id="729" name="Rectangle 2"/>
+          <p:cNvPr id="736" name="Rectangle 2"/>
           <p:cNvSpPr/>
           <p:nvPr/>
         </p:nvSpPr>
@@ -25259,7 +25600,7 @@
       </p:sp>
       <p:sp>
         <p:nvSpPr>
-          <p:cNvPr id="730" name="Rectangle 3"/>
+          <p:cNvPr id="737" name="Rectangle 3"/>
           <p:cNvSpPr/>
           <p:nvPr/>
         </p:nvSpPr>
@@ -25319,7 +25660,7 @@
       </p:sp>
       <p:sp>
         <p:nvSpPr>
-          <p:cNvPr id="731" name="Rectangle 4"/>
+          <p:cNvPr id="738" name="Rectangle 4"/>
           <p:cNvSpPr/>
           <p:nvPr/>
         </p:nvSpPr>
@@ -25377,7 +25718,7 @@
       </p:sp>
       <p:sp>
         <p:nvSpPr>
-          <p:cNvPr id="732" name="Rectangle 5"/>
+          <p:cNvPr id="739" name="Rectangle 5"/>
           <p:cNvSpPr/>
           <p:nvPr/>
         </p:nvSpPr>
@@ -25435,7 +25776,7 @@
       </p:sp>
       <p:sp>
         <p:nvSpPr>
-          <p:cNvPr id="733" name="Rectangle 6"/>
+          <p:cNvPr id="740" name="Rectangle 6"/>
           <p:cNvSpPr/>
           <p:nvPr/>
         </p:nvSpPr>
@@ -25480,7 +25821,7 @@
       </p:sp>
       <p:sp>
         <p:nvSpPr>
-          <p:cNvPr id="734" name="Rectangle 7"/>
+          <p:cNvPr id="741" name="Rectangle 7"/>
           <p:cNvSpPr/>
           <p:nvPr/>
         </p:nvSpPr>
@@ -25538,7 +25879,7 @@
       </p:sp>
       <p:sp>
         <p:nvSpPr>
-          <p:cNvPr id="735" name="Rectangle 8"/>
+          <p:cNvPr id="742" name="Rectangle 8"/>
           <p:cNvSpPr/>
           <p:nvPr/>
         </p:nvSpPr>
@@ -25596,7 +25937,7 @@
       </p:sp>
       <p:sp>
         <p:nvSpPr>
-          <p:cNvPr id="736" name="Rectangle 9"/>
+          <p:cNvPr id="743" name="Rectangle 9"/>
           <p:cNvSpPr/>
           <p:nvPr/>
         </p:nvSpPr>
@@ -25654,7 +25995,7 @@
       </p:sp>
       <p:sp>
         <p:nvSpPr>
-          <p:cNvPr id="737" name="Rectangle 10"/>
+          <p:cNvPr id="744" name="Rectangle 10"/>
           <p:cNvSpPr/>
           <p:nvPr/>
         </p:nvSpPr>
@@ -25712,7 +26053,7 @@
       </p:sp>
       <p:sp>
         <p:nvSpPr>
-          <p:cNvPr id="738" name="Rectangle 11"/>
+          <p:cNvPr id="745" name="Rectangle 11"/>
           <p:cNvSpPr/>
           <p:nvPr/>
         </p:nvSpPr>
@@ -25759,7 +26100,7 @@
       </p:sp>
       <p:sp>
         <p:nvSpPr>
-          <p:cNvPr id="739" name="Oval 12"/>
+          <p:cNvPr id="746" name="Oval 12"/>
           <p:cNvSpPr/>
           <p:nvPr/>
         </p:nvSpPr>
@@ -25819,7 +26160,7 @@
       </p:sp>
       <p:sp>
         <p:nvSpPr>
-          <p:cNvPr id="740" name="Rectangle 13"/>
+          <p:cNvPr id="747" name="Rectangle 13"/>
           <p:cNvSpPr/>
           <p:nvPr/>
         </p:nvSpPr>
@@ -25877,7 +26218,7 @@
       </p:sp>
       <p:sp>
         <p:nvSpPr>
-          <p:cNvPr id="741" name="Rectangle 14"/>
+          <p:cNvPr id="748" name="Rectangle 14"/>
           <p:cNvSpPr/>
           <p:nvPr/>
         </p:nvSpPr>
@@ -25924,7 +26265,7 @@
       </p:sp>
       <p:sp>
         <p:nvSpPr>
-          <p:cNvPr id="742" name="Oval 15"/>
+          <p:cNvPr id="749" name="Oval 15"/>
           <p:cNvSpPr/>
           <p:nvPr/>
         </p:nvSpPr>
@@ -25984,7 +26325,7 @@
       </p:sp>
       <p:sp>
         <p:nvSpPr>
-          <p:cNvPr id="743" name="Rectangle 16"/>
+          <p:cNvPr id="750" name="Rectangle 16"/>
           <p:cNvSpPr/>
           <p:nvPr/>
         </p:nvSpPr>
@@ -26042,7 +26383,7 @@
       </p:sp>
       <p:sp>
         <p:nvSpPr>
-          <p:cNvPr id="744" name="Picture"/>
+          <p:cNvPr id="751" name="Picture"/>
           <p:cNvSpPr/>
           <p:nvPr/>
         </p:nvSpPr>
@@ -26161,7 +26502,7 @@
       </p:sp>
       <p:sp>
         <p:nvSpPr>
-          <p:cNvPr id="745" name="Rectangle 18"/>
+          <p:cNvPr id="752" name="Rectangle 18"/>
           <p:cNvSpPr/>
           <p:nvPr/>
         </p:nvSpPr>
@@ -26219,7 +26560,7 @@
       </p:sp>
       <p:sp>
         <p:nvSpPr>
-          <p:cNvPr id="746" name="Rectangle 19"/>
+          <p:cNvPr id="753" name="Rectangle 19"/>
           <p:cNvSpPr/>
           <p:nvPr/>
         </p:nvSpPr>
@@ -26264,7 +26605,7 @@
       </p:sp>
       <p:sp>
         <p:nvSpPr>
-          <p:cNvPr id="747" name="Document"/>
+          <p:cNvPr id="754" name="Document"/>
           <p:cNvSpPr/>
           <p:nvPr/>
         </p:nvSpPr>
@@ -26382,7 +26723,7 @@
       </p:sp>
       <p:sp>
         <p:nvSpPr>
-          <p:cNvPr id="748" name="Rectangle 21"/>
+          <p:cNvPr id="755" name="Rectangle 21"/>
           <p:cNvSpPr/>
           <p:nvPr/>
         </p:nvSpPr>
@@ -26440,7 +26781,7 @@
       </p:sp>
       <p:sp>
         <p:nvSpPr>
-          <p:cNvPr id="1134" name="Slide Number Placeholder"/>
+          <p:cNvPr id="1141" name="Slide Number Placeholder"/>
           <p:cNvSpPr>
             <a:spLocks noGrp="1"/>
           </p:cNvSpPr>
@@ -26487,7 +26828,7 @@
       </p:grpSpPr>
       <p:sp>
         <p:nvSpPr>
-          <p:cNvPr id="750" name="Rectangle 1"/>
+          <p:cNvPr id="757" name="Rectangle 1"/>
           <p:cNvSpPr/>
           <p:nvPr/>
         </p:nvSpPr>
@@ -26532,7 +26873,7 @@
       </p:sp>
       <p:sp>
         <p:nvSpPr>
-          <p:cNvPr id="751" name="Rectangle 2"/>
+          <p:cNvPr id="758" name="Rectangle 2"/>
           <p:cNvSpPr/>
           <p:nvPr/>
         </p:nvSpPr>
@@ -26590,7 +26931,7 @@
       </p:sp>
       <p:sp>
         <p:nvSpPr>
-          <p:cNvPr id="752" name="Rectangle 3"/>
+          <p:cNvPr id="759" name="Rectangle 3"/>
           <p:cNvSpPr/>
           <p:nvPr/>
         </p:nvSpPr>
@@ -26650,7 +26991,7 @@
       </p:sp>
       <p:sp>
         <p:nvSpPr>
-          <p:cNvPr id="753" name="Rectangle 4"/>
+          <p:cNvPr id="760" name="Rectangle 4"/>
           <p:cNvSpPr/>
           <p:nvPr/>
         </p:nvSpPr>
@@ -26708,7 +27049,7 @@
       </p:sp>
       <p:sp>
         <p:nvSpPr>
-          <p:cNvPr id="754" name="Rectangle 5"/>
+          <p:cNvPr id="761" name="Rectangle 5"/>
           <p:cNvSpPr/>
           <p:nvPr/>
         </p:nvSpPr>
@@ -26766,7 +27107,7 @@
       </p:sp>
       <p:sp>
         <p:nvSpPr>
-          <p:cNvPr id="755" name="Rectangle 6"/>
+          <p:cNvPr id="762" name="Rectangle 6"/>
           <p:cNvSpPr/>
           <p:nvPr/>
         </p:nvSpPr>
@@ -26811,7 +27152,7 @@
       </p:sp>
       <p:sp>
         <p:nvSpPr>
-          <p:cNvPr id="756" name="Rectangle 7"/>
+          <p:cNvPr id="763" name="Rectangle 7"/>
           <p:cNvSpPr/>
           <p:nvPr/>
         </p:nvSpPr>
@@ -26869,7 +27210,7 @@
       </p:sp>
       <p:sp>
         <p:nvSpPr>
-          <p:cNvPr id="757" name="Rectangle 8"/>
+          <p:cNvPr id="764" name="Rectangle 8"/>
           <p:cNvSpPr/>
           <p:nvPr/>
         </p:nvSpPr>
@@ -26927,7 +27268,7 @@
       </p:sp>
       <p:sp>
         <p:nvSpPr>
-          <p:cNvPr id="758" name="Rectangle 9"/>
+          <p:cNvPr id="765" name="Rectangle 9"/>
           <p:cNvSpPr/>
           <p:nvPr/>
         </p:nvSpPr>
@@ -26985,7 +27326,7 @@
       </p:sp>
       <p:sp>
         <p:nvSpPr>
-          <p:cNvPr id="759" name="Rectangle 10"/>
+          <p:cNvPr id="766" name="Rectangle 10"/>
           <p:cNvSpPr/>
           <p:nvPr/>
         </p:nvSpPr>
@@ -27043,7 +27384,7 @@
       </p:sp>
       <p:sp>
         <p:nvSpPr>
-          <p:cNvPr id="760" name="Rectangle 11"/>
+          <p:cNvPr id="767" name="Rectangle 11"/>
           <p:cNvSpPr/>
           <p:nvPr/>
         </p:nvSpPr>
@@ -27090,7 +27431,7 @@
       </p:sp>
       <p:sp>
         <p:nvSpPr>
-          <p:cNvPr id="761" name="Oval 12"/>
+          <p:cNvPr id="768" name="Oval 12"/>
           <p:cNvSpPr/>
           <p:nvPr/>
         </p:nvSpPr>
@@ -27150,7 +27491,7 @@
       </p:sp>
       <p:sp>
         <p:nvSpPr>
-          <p:cNvPr id="762" name="Rectangle 13"/>
+          <p:cNvPr id="769" name="Rectangle 13"/>
           <p:cNvSpPr/>
           <p:nvPr/>
         </p:nvSpPr>
@@ -27208,7 +27549,7 @@
       </p:sp>
       <p:sp>
         <p:nvSpPr>
-          <p:cNvPr id="763" name="Rectangle 14"/>
+          <p:cNvPr id="770" name="Rectangle 14"/>
           <p:cNvSpPr/>
           <p:nvPr/>
         </p:nvSpPr>
@@ -27255,7 +27596,7 @@
       </p:sp>
       <p:sp>
         <p:nvSpPr>
-          <p:cNvPr id="764" name="Oval 15"/>
+          <p:cNvPr id="771" name="Oval 15"/>
           <p:cNvSpPr/>
           <p:nvPr/>
         </p:nvSpPr>
@@ -27315,7 +27656,7 @@
       </p:sp>
       <p:sp>
         <p:nvSpPr>
-          <p:cNvPr id="765" name="Rectangle 16"/>
+          <p:cNvPr id="772" name="Rectangle 16"/>
           <p:cNvSpPr/>
           <p:nvPr/>
         </p:nvSpPr>
@@ -27373,7 +27714,7 @@
       </p:sp>
       <p:sp>
         <p:nvSpPr>
-          <p:cNvPr id="766" name="Picture"/>
+          <p:cNvPr id="773" name="Picture"/>
           <p:cNvSpPr/>
           <p:nvPr/>
         </p:nvSpPr>
@@ -27492,7 +27833,7 @@
       </p:sp>
       <p:sp>
         <p:nvSpPr>
-          <p:cNvPr id="767" name="Rectangle 18"/>
+          <p:cNvPr id="774" name="Rectangle 18"/>
           <p:cNvSpPr/>
           <p:nvPr/>
         </p:nvSpPr>
@@ -27550,7 +27891,7 @@
       </p:sp>
       <p:sp>
         <p:nvSpPr>
-          <p:cNvPr id="768" name="Rectangle 19"/>
+          <p:cNvPr id="775" name="Rectangle 19"/>
           <p:cNvSpPr/>
           <p:nvPr/>
         </p:nvSpPr>
@@ -27595,7 +27936,7 @@
       </p:sp>
       <p:sp>
         <p:nvSpPr>
-          <p:cNvPr id="769" name="Document"/>
+          <p:cNvPr id="776" name="Document"/>
           <p:cNvSpPr/>
           <p:nvPr/>
         </p:nvSpPr>
@@ -27713,7 +28054,7 @@
       </p:sp>
       <p:sp>
         <p:nvSpPr>
-          <p:cNvPr id="770" name="Rectangle 21"/>
+          <p:cNvPr id="777" name="Rectangle 21"/>
           <p:cNvSpPr/>
           <p:nvPr/>
         </p:nvSpPr>
@@ -27771,7 +28112,7 @@
       </p:sp>
       <p:sp>
         <p:nvSpPr>
-          <p:cNvPr id="1137" name="Slide Number Placeholder"/>
+          <p:cNvPr id="1144" name="Slide Number Placeholder"/>
           <p:cNvSpPr>
             <a:spLocks noGrp="1"/>
           </p:cNvSpPr>
@@ -27818,7 +28159,7 @@
       </p:grpSpPr>
       <p:sp>
         <p:nvSpPr>
-          <p:cNvPr id="772" name="Rectangle 1"/>
+          <p:cNvPr id="779" name="Rectangle 1"/>
           <p:cNvSpPr/>
           <p:nvPr/>
         </p:nvSpPr>
@@ -27863,7 +28204,7 @@
       </p:sp>
       <p:sp>
         <p:nvSpPr>
-          <p:cNvPr id="773" name="Rectangle 2"/>
+          <p:cNvPr id="780" name="Rectangle 2"/>
           <p:cNvSpPr/>
           <p:nvPr/>
         </p:nvSpPr>
@@ -27921,7 +28262,7 @@
       </p:sp>
       <p:sp>
         <p:nvSpPr>
-          <p:cNvPr id="774" name="Rectangle 3"/>
+          <p:cNvPr id="781" name="Rectangle 3"/>
           <p:cNvSpPr/>
           <p:nvPr/>
         </p:nvSpPr>
@@ -27981,7 +28322,7 @@
       </p:sp>
       <p:sp>
         <p:nvSpPr>
-          <p:cNvPr id="775" name="Rectangle 4"/>
+          <p:cNvPr id="782" name="Rectangle 4"/>
           <p:cNvSpPr/>
           <p:nvPr/>
         </p:nvSpPr>
@@ -28039,7 +28380,7 @@
       </p:sp>
       <p:sp>
         <p:nvSpPr>
-          <p:cNvPr id="776" name="Rectangle 5"/>
+          <p:cNvPr id="783" name="Rectangle 5"/>
           <p:cNvSpPr/>
           <p:nvPr/>
         </p:nvSpPr>
@@ -28097,7 +28438,7 @@
       </p:sp>
       <p:sp>
         <p:nvSpPr>
-          <p:cNvPr id="777" name="Rectangle 6"/>
+          <p:cNvPr id="784" name="Rectangle 6"/>
           <p:cNvSpPr/>
           <p:nvPr/>
         </p:nvSpPr>
@@ -28142,7 +28483,7 @@
       </p:sp>
       <p:sp>
         <p:nvSpPr>
-          <p:cNvPr id="778" name="Rectangle 7"/>
+          <p:cNvPr id="785" name="Rectangle 7"/>
           <p:cNvSpPr/>
           <p:nvPr/>
         </p:nvSpPr>
@@ -28200,7 +28541,7 @@
       </p:sp>
       <p:sp>
         <p:nvSpPr>
-          <p:cNvPr id="779" name="Rectangle 8"/>
+          <p:cNvPr id="786" name="Rectangle 8"/>
           <p:cNvSpPr/>
           <p:nvPr/>
         </p:nvSpPr>
@@ -28258,7 +28599,7 @@
       </p:sp>
       <p:sp>
         <p:nvSpPr>
-          <p:cNvPr id="780" name="Rectangle 9"/>
+          <p:cNvPr id="787" name="Rectangle 9"/>
           <p:cNvSpPr/>
           <p:nvPr/>
         </p:nvSpPr>
@@ -28316,7 +28657,7 @@
       </p:sp>
       <p:sp>
         <p:nvSpPr>
-          <p:cNvPr id="781" name="Rectangle 10"/>
+          <p:cNvPr id="788" name="Rectangle 10"/>
           <p:cNvSpPr/>
           <p:nvPr/>
         </p:nvSpPr>
@@ -28374,7 +28715,7 @@
       </p:sp>
       <p:sp>
         <p:nvSpPr>
-          <p:cNvPr id="782" name="Rectangle 11"/>
+          <p:cNvPr id="789" name="Rectangle 11"/>
           <p:cNvSpPr/>
           <p:nvPr/>
         </p:nvSpPr>
@@ -28421,7 +28762,7 @@
       </p:sp>
       <p:sp>
         <p:nvSpPr>
-          <p:cNvPr id="783" name="Oval 12"/>
+          <p:cNvPr id="790" name="Oval 12"/>
           <p:cNvSpPr/>
           <p:nvPr/>
         </p:nvSpPr>
@@ -28481,7 +28822,7 @@
       </p:sp>
       <p:sp>
         <p:nvSpPr>
-          <p:cNvPr id="784" name="Rectangle 13"/>
+          <p:cNvPr id="791" name="Rectangle 13"/>
           <p:cNvSpPr/>
           <p:nvPr/>
         </p:nvSpPr>
@@ -28539,7 +28880,7 @@
       </p:sp>
       <p:sp>
         <p:nvSpPr>
-          <p:cNvPr id="785" name="Rectangle 14"/>
+          <p:cNvPr id="792" name="Rectangle 14"/>
           <p:cNvSpPr/>
           <p:nvPr/>
         </p:nvSpPr>
@@ -28586,7 +28927,7 @@
       </p:sp>
       <p:sp>
         <p:nvSpPr>
-          <p:cNvPr id="786" name="Oval 15"/>
+          <p:cNvPr id="793" name="Oval 15"/>
           <p:cNvSpPr/>
           <p:nvPr/>
         </p:nvSpPr>
@@ -28646,7 +28987,7 @@
       </p:sp>
       <p:sp>
         <p:nvSpPr>
-          <p:cNvPr id="787" name="Rectangle 16"/>
+          <p:cNvPr id="794" name="Rectangle 16"/>
           <p:cNvSpPr/>
           <p:nvPr/>
         </p:nvSpPr>
@@ -28704,7 +29045,7 @@
       </p:sp>
       <p:sp>
         <p:nvSpPr>
-          <p:cNvPr id="788" name="Picture"/>
+          <p:cNvPr id="795" name="Picture"/>
           <p:cNvSpPr/>
           <p:nvPr/>
         </p:nvSpPr>
@@ -28823,7 +29164,7 @@
       </p:sp>
       <p:sp>
         <p:nvSpPr>
-          <p:cNvPr id="789" name="Rectangle 18"/>
+          <p:cNvPr id="796" name="Rectangle 18"/>
           <p:cNvSpPr/>
           <p:nvPr/>
         </p:nvSpPr>
@@ -28881,7 +29222,7 @@
       </p:sp>
       <p:sp>
         <p:nvSpPr>
-          <p:cNvPr id="790" name="Rectangle 19"/>
+          <p:cNvPr id="797" name="Rectangle 19"/>
           <p:cNvSpPr/>
           <p:nvPr/>
         </p:nvSpPr>
@@ -28926,7 +29267,7 @@
       </p:sp>
       <p:sp>
         <p:nvSpPr>
-          <p:cNvPr id="791" name="Document"/>
+          <p:cNvPr id="798" name="Document"/>
           <p:cNvSpPr/>
           <p:nvPr/>
         </p:nvSpPr>
@@ -29044,7 +29385,7 @@
       </p:sp>
       <p:sp>
         <p:nvSpPr>
-          <p:cNvPr id="792" name="Rectangle 21"/>
+          <p:cNvPr id="799" name="Rectangle 21"/>
           <p:cNvSpPr/>
           <p:nvPr/>
         </p:nvSpPr>
@@ -29102,7 +29443,7 @@
       </p:sp>
       <p:sp>
         <p:nvSpPr>
-          <p:cNvPr id="1140" name="Slide Number Placeholder"/>
+          <p:cNvPr id="1147" name="Slide Number Placeholder"/>
           <p:cNvSpPr>
             <a:spLocks noGrp="1"/>
           </p:cNvSpPr>
@@ -29149,7 +29490,7 @@
       </p:grpSpPr>
       <p:sp>
         <p:nvSpPr>
-          <p:cNvPr id="794" name="Rectangle 1"/>
+          <p:cNvPr id="801" name="Rectangle 1"/>
           <p:cNvSpPr/>
           <p:nvPr/>
         </p:nvSpPr>
@@ -29194,7 +29535,7 @@
       </p:sp>
       <p:sp>
         <p:nvSpPr>
-          <p:cNvPr id="795" name="Rectangle 2"/>
+          <p:cNvPr id="802" name="Rectangle 2"/>
           <p:cNvSpPr/>
           <p:nvPr/>
         </p:nvSpPr>
@@ -29252,7 +29593,7 @@
       </p:sp>
       <p:sp>
         <p:nvSpPr>
-          <p:cNvPr id="796" name="Rectangle 3"/>
+          <p:cNvPr id="803" name="Rectangle 3"/>
           <p:cNvSpPr/>
           <p:nvPr/>
         </p:nvSpPr>
@@ -29312,7 +29653,7 @@
       </p:sp>
       <p:sp>
         <p:nvSpPr>
-          <p:cNvPr id="797" name="Rectangle 4"/>
+          <p:cNvPr id="804" name="Rectangle 4"/>
           <p:cNvSpPr/>
           <p:nvPr/>
         </p:nvSpPr>
@@ -29370,7 +29711,7 @@
       </p:sp>
       <p:sp>
         <p:nvSpPr>
-          <p:cNvPr id="798" name="Rectangle 5"/>
+          <p:cNvPr id="805" name="Rectangle 5"/>
           <p:cNvSpPr/>
           <p:nvPr/>
         </p:nvSpPr>
@@ -29428,7 +29769,7 @@
       </p:sp>
       <p:sp>
         <p:nvSpPr>
-          <p:cNvPr id="799" name="Rectangle 6"/>
+          <p:cNvPr id="806" name="Rectangle 6"/>
           <p:cNvSpPr/>
           <p:nvPr/>
         </p:nvSpPr>
@@ -29473,7 +29814,7 @@
       </p:sp>
       <p:sp>
         <p:nvSpPr>
-          <p:cNvPr id="800" name="Rectangle 7"/>
+          <p:cNvPr id="807" name="Rectangle 7"/>
           <p:cNvSpPr/>
           <p:nvPr/>
         </p:nvSpPr>
@@ -29531,7 +29872,7 @@
       </p:sp>
       <p:sp>
         <p:nvSpPr>
-          <p:cNvPr id="801" name="Rectangle 8"/>
+          <p:cNvPr id="808" name="Rectangle 8"/>
           <p:cNvSpPr/>
           <p:nvPr/>
         </p:nvSpPr>
@@ -29589,7 +29930,7 @@
       </p:sp>
       <p:sp>
         <p:nvSpPr>
-          <p:cNvPr id="802" name="Rectangle 9"/>
+          <p:cNvPr id="809" name="Rectangle 9"/>
           <p:cNvSpPr/>
           <p:nvPr/>
         </p:nvSpPr>
@@ -29647,7 +29988,7 @@
       </p:sp>
       <p:sp>
         <p:nvSpPr>
-          <p:cNvPr id="803" name="Rectangle 10"/>
+          <p:cNvPr id="810" name="Rectangle 10"/>
           <p:cNvSpPr/>
           <p:nvPr/>
         </p:nvSpPr>
@@ -29705,7 +30046,7 @@
       </p:sp>
       <p:sp>
         <p:nvSpPr>
-          <p:cNvPr id="804" name="Rectangle 11"/>
+          <p:cNvPr id="811" name="Rectangle 11"/>
           <p:cNvSpPr/>
           <p:nvPr/>
         </p:nvSpPr>
@@ -29752,7 +30093,7 @@
       </p:sp>
       <p:sp>
         <p:nvSpPr>
-          <p:cNvPr id="805" name="Oval 12"/>
+          <p:cNvPr id="812" name="Oval 12"/>
           <p:cNvSpPr/>
           <p:nvPr/>
         </p:nvSpPr>
@@ -29812,7 +30153,7 @@
       </p:sp>
       <p:sp>
         <p:nvSpPr>
-          <p:cNvPr id="806" name="Rectangle 13"/>
+          <p:cNvPr id="813" name="Rectangle 13"/>
           <p:cNvSpPr/>
           <p:nvPr/>
         </p:nvSpPr>
@@ -29870,7 +30211,7 @@
       </p:sp>
       <p:sp>
         <p:nvSpPr>
-          <p:cNvPr id="807" name="Rectangle 14"/>
+          <p:cNvPr id="814" name="Rectangle 14"/>
           <p:cNvSpPr/>
           <p:nvPr/>
         </p:nvSpPr>
@@ -29917,7 +30258,7 @@
       </p:sp>
       <p:sp>
         <p:nvSpPr>
-          <p:cNvPr id="808" name="Oval 15"/>
+          <p:cNvPr id="815" name="Oval 15"/>
           <p:cNvSpPr/>
           <p:nvPr/>
         </p:nvSpPr>
@@ -29977,7 +30318,7 @@
       </p:sp>
       <p:sp>
         <p:nvSpPr>
-          <p:cNvPr id="809" name="Rectangle 16"/>
+          <p:cNvPr id="816" name="Rectangle 16"/>
           <p:cNvSpPr/>
           <p:nvPr/>
         </p:nvSpPr>
@@ -30035,7 +30376,7 @@
       </p:sp>
       <p:sp>
         <p:nvSpPr>
-          <p:cNvPr id="810" name="Picture"/>
+          <p:cNvPr id="817" name="Picture"/>
           <p:cNvSpPr/>
           <p:nvPr/>
         </p:nvSpPr>
@@ -30154,7 +30495,7 @@
       </p:sp>
       <p:sp>
         <p:nvSpPr>
-          <p:cNvPr id="811" name="Rectangle 18"/>
+          <p:cNvPr id="818" name="Rectangle 18"/>
           <p:cNvSpPr/>
           <p:nvPr/>
         </p:nvSpPr>
@@ -30212,7 +30553,7 @@
       </p:sp>
       <p:sp>
         <p:nvSpPr>
-          <p:cNvPr id="812" name="Rectangle 19"/>
+          <p:cNvPr id="819" name="Rectangle 19"/>
           <p:cNvSpPr/>
           <p:nvPr/>
         </p:nvSpPr>
@@ -30257,7 +30598,7 @@
       </p:sp>
       <p:sp>
         <p:nvSpPr>
-          <p:cNvPr id="813" name="Document"/>
+          <p:cNvPr id="820" name="Document"/>
           <p:cNvSpPr/>
           <p:nvPr/>
         </p:nvSpPr>
@@ -30375,7 +30716,7 @@
       </p:sp>
       <p:sp>
         <p:nvSpPr>
-          <p:cNvPr id="814" name="Rectangle 21"/>
+          <p:cNvPr id="821" name="Rectangle 21"/>
           <p:cNvSpPr/>
           <p:nvPr/>
         </p:nvSpPr>
@@ -30433,7 +30774,7 @@
       </p:sp>
       <p:sp>
         <p:nvSpPr>
-          <p:cNvPr id="1143" name="Slide Number Placeholder"/>
+          <p:cNvPr id="1150" name="Slide Number Placeholder"/>
           <p:cNvSpPr>
             <a:spLocks noGrp="1"/>
           </p:cNvSpPr>
@@ -30480,7 +30821,7 @@
       </p:grpSpPr>
       <p:sp>
         <p:nvSpPr>
-          <p:cNvPr id="816" name="Rectangle 1"/>
+          <p:cNvPr id="823" name="Rectangle 1"/>
           <p:cNvSpPr/>
           <p:nvPr/>
         </p:nvSpPr>
@@ -30525,7 +30866,7 @@
       </p:sp>
       <p:sp>
         <p:nvSpPr>
-          <p:cNvPr id="817" name="Rectangle 2"/>
+          <p:cNvPr id="824" name="Rectangle 2"/>
           <p:cNvSpPr/>
           <p:nvPr/>
         </p:nvSpPr>
@@ -30583,7 +30924,7 @@
       </p:sp>
       <p:sp>
         <p:nvSpPr>
-          <p:cNvPr id="818" name="Rectangle 3"/>
+          <p:cNvPr id="825" name="Rectangle 3"/>
           <p:cNvSpPr/>
           <p:nvPr/>
         </p:nvSpPr>
@@ -30643,7 +30984,7 @@
       </p:sp>
       <p:sp>
         <p:nvSpPr>
-          <p:cNvPr id="819" name="Rectangle 4"/>
+          <p:cNvPr id="826" name="Rectangle 4"/>
           <p:cNvSpPr/>
           <p:nvPr/>
         </p:nvSpPr>
@@ -30701,7 +31042,7 @@
       </p:sp>
       <p:sp>
         <p:nvSpPr>
-          <p:cNvPr id="820" name="Rectangle 5"/>
+          <p:cNvPr id="827" name="Rectangle 5"/>
           <p:cNvSpPr/>
           <p:nvPr/>
         </p:nvSpPr>
@@ -30759,7 +31100,7 @@
       </p:sp>
       <p:sp>
         <p:nvSpPr>
-          <p:cNvPr id="821" name="Rectangle 6"/>
+          <p:cNvPr id="828" name="Rectangle 6"/>
           <p:cNvSpPr/>
           <p:nvPr/>
         </p:nvSpPr>
@@ -30804,7 +31145,7 @@
       </p:sp>
       <p:sp>
         <p:nvSpPr>
-          <p:cNvPr id="822" name="Rectangle 7"/>
+          <p:cNvPr id="829" name="Rectangle 7"/>
           <p:cNvSpPr/>
           <p:nvPr/>
         </p:nvSpPr>
@@ -30862,7 +31203,7 @@
       </p:sp>
       <p:sp>
         <p:nvSpPr>
-          <p:cNvPr id="823" name="Rectangle 8"/>
+          <p:cNvPr id="830" name="Rectangle 8"/>
           <p:cNvSpPr/>
           <p:nvPr/>
         </p:nvSpPr>
@@ -30920,7 +31261,7 @@
       </p:sp>
       <p:sp>
         <p:nvSpPr>
-          <p:cNvPr id="824" name="Rectangle 9"/>
+          <p:cNvPr id="831" name="Rectangle 9"/>
           <p:cNvSpPr/>
           <p:nvPr/>
         </p:nvSpPr>
@@ -30978,7 +31319,7 @@
       </p:sp>
       <p:sp>
         <p:nvSpPr>
-          <p:cNvPr id="825" name="Rectangle 10"/>
+          <p:cNvPr id="832" name="Rectangle 10"/>
           <p:cNvSpPr/>
           <p:nvPr/>
         </p:nvSpPr>
@@ -31036,7 +31377,7 @@
       </p:sp>
       <p:sp>
         <p:nvSpPr>
-          <p:cNvPr id="826" name="Rectangle 11"/>
+          <p:cNvPr id="833" name="Rectangle 11"/>
           <p:cNvSpPr/>
           <p:nvPr/>
         </p:nvSpPr>
@@ -31083,7 +31424,7 @@
       </p:sp>
       <p:sp>
         <p:nvSpPr>
-          <p:cNvPr id="827" name="Oval 12"/>
+          <p:cNvPr id="834" name="Oval 12"/>
           <p:cNvSpPr/>
           <p:nvPr/>
         </p:nvSpPr>
@@ -31143,7 +31484,7 @@
       </p:sp>
       <p:sp>
         <p:nvSpPr>
-          <p:cNvPr id="828" name="Rectangle 13"/>
+          <p:cNvPr id="835" name="Rectangle 13"/>
           <p:cNvSpPr/>
           <p:nvPr/>
         </p:nvSpPr>
@@ -31201,7 +31542,7 @@
       </p:sp>
       <p:sp>
         <p:nvSpPr>
-          <p:cNvPr id="829" name="Rectangle 14"/>
+          <p:cNvPr id="836" name="Rectangle 14"/>
           <p:cNvSpPr/>
           <p:nvPr/>
         </p:nvSpPr>
@@ -31248,7 +31589,7 @@
       </p:sp>
       <p:sp>
         <p:nvSpPr>
-          <p:cNvPr id="830" name="Oval 15"/>
+          <p:cNvPr id="837" name="Oval 15"/>
           <p:cNvSpPr/>
           <p:nvPr/>
         </p:nvSpPr>
@@ -31308,7 +31649,7 @@
       </p:sp>
       <p:sp>
         <p:nvSpPr>
-          <p:cNvPr id="831" name="Rectangle 16"/>
+          <p:cNvPr id="838" name="Rectangle 16"/>
           <p:cNvSpPr/>
           <p:nvPr/>
         </p:nvSpPr>
@@ -31366,7 +31707,7 @@
       </p:sp>
       <p:sp>
         <p:nvSpPr>
-          <p:cNvPr id="832" name="Rectangle 17"/>
+          <p:cNvPr id="839" name="Rectangle 17"/>
           <p:cNvSpPr/>
           <p:nvPr/>
         </p:nvSpPr>
@@ -31413,7 +31754,7 @@
       </p:sp>
       <p:sp>
         <p:nvSpPr>
-          <p:cNvPr id="833" name="Oval 18"/>
+          <p:cNvPr id="840" name="Oval 18"/>
           <p:cNvSpPr/>
           <p:nvPr/>
         </p:nvSpPr>
@@ -31473,7 +31814,7 @@
       </p:sp>
       <p:sp>
         <p:nvSpPr>
-          <p:cNvPr id="834" name="Rectangle 19"/>
+          <p:cNvPr id="841" name="Rectangle 19"/>
           <p:cNvSpPr/>
           <p:nvPr/>
         </p:nvSpPr>
@@ -31531,7 +31872,7 @@
       </p:sp>
       <p:sp>
         <p:nvSpPr>
-          <p:cNvPr id="835" name="Picture"/>
+          <p:cNvPr id="842" name="Picture"/>
           <p:cNvSpPr/>
           <p:nvPr/>
         </p:nvSpPr>
@@ -31650,7 +31991,7 @@
       </p:sp>
       <p:sp>
         <p:nvSpPr>
-          <p:cNvPr id="836" name="Rectangle 21"/>
+          <p:cNvPr id="843" name="Rectangle 21"/>
           <p:cNvSpPr/>
           <p:nvPr/>
         </p:nvSpPr>
@@ -31708,7 +32049,7 @@
       </p:sp>
       <p:sp>
         <p:nvSpPr>
-          <p:cNvPr id="837" name="Rectangle 22"/>
+          <p:cNvPr id="844" name="Rectangle 22"/>
           <p:cNvSpPr/>
           <p:nvPr/>
         </p:nvSpPr>
@@ -31753,7 +32094,7 @@
       </p:sp>
       <p:sp>
         <p:nvSpPr>
-          <p:cNvPr id="838" name="Document"/>
+          <p:cNvPr id="845" name="Document"/>
           <p:cNvSpPr/>
           <p:nvPr/>
         </p:nvSpPr>
@@ -31871,7 +32212,7 @@
       </p:sp>
       <p:sp>
         <p:nvSpPr>
-          <p:cNvPr id="839" name="Rectangle 24"/>
+          <p:cNvPr id="846" name="Rectangle 24"/>
           <p:cNvSpPr/>
           <p:nvPr/>
         </p:nvSpPr>
@@ -31929,7 +32270,7 @@
       </p:sp>
       <p:sp>
         <p:nvSpPr>
-          <p:cNvPr id="1146" name="Slide Number Placeholder"/>
+          <p:cNvPr id="1153" name="Slide Number Placeholder"/>
           <p:cNvSpPr>
             <a:spLocks noGrp="1"/>
           </p:cNvSpPr>
@@ -31976,7 +32317,7 @@
       </p:grpSpPr>
       <p:sp>
         <p:nvSpPr>
-          <p:cNvPr id="841" name="Rectangle 1"/>
+          <p:cNvPr id="848" name="Rectangle 1"/>
           <p:cNvSpPr/>
           <p:nvPr/>
         </p:nvSpPr>
@@ -32021,7 +32362,7 @@
       </p:sp>
       <p:sp>
         <p:nvSpPr>
-          <p:cNvPr id="842" name="Rectangle 2"/>
+          <p:cNvPr id="849" name="Rectangle 2"/>
           <p:cNvSpPr/>
           <p:nvPr/>
         </p:nvSpPr>
@@ -32079,7 +32420,7 @@
       </p:sp>
       <p:sp>
         <p:nvSpPr>
-          <p:cNvPr id="843" name="Rectangle 3"/>
+          <p:cNvPr id="850" name="Rectangle 3"/>
           <p:cNvSpPr/>
           <p:nvPr/>
         </p:nvSpPr>
@@ -32139,7 +32480,7 @@
       </p:sp>
       <p:sp>
         <p:nvSpPr>
-          <p:cNvPr id="844" name="Rectangle 4"/>
+          <p:cNvPr id="851" name="Rectangle 4"/>
           <p:cNvSpPr/>
           <p:nvPr/>
         </p:nvSpPr>
@@ -32197,7 +32538,7 @@
       </p:sp>
       <p:sp>
         <p:nvSpPr>
-          <p:cNvPr id="845" name="Rectangle 5"/>
+          <p:cNvPr id="852" name="Rectangle 5"/>
           <p:cNvSpPr/>
           <p:nvPr/>
         </p:nvSpPr>
@@ -32255,7 +32596,7 @@
       </p:sp>
       <p:sp>
         <p:nvSpPr>
-          <p:cNvPr id="846" name="Rectangle 6"/>
+          <p:cNvPr id="853" name="Rectangle 6"/>
           <p:cNvSpPr/>
           <p:nvPr/>
         </p:nvSpPr>
@@ -32300,7 +32641,7 @@
       </p:sp>
       <p:sp>
         <p:nvSpPr>
-          <p:cNvPr id="847" name="Rectangle 7"/>
+          <p:cNvPr id="854" name="Rectangle 7"/>
           <p:cNvSpPr/>
           <p:nvPr/>
         </p:nvSpPr>
@@ -32358,7 +32699,7 @@
       </p:sp>
       <p:sp>
         <p:nvSpPr>
-          <p:cNvPr id="848" name="Rectangle 8"/>
+          <p:cNvPr id="855" name="Rectangle 8"/>
           <p:cNvSpPr/>
           <p:nvPr/>
         </p:nvSpPr>
@@ -32416,7 +32757,7 @@
       </p:sp>
       <p:sp>
         <p:nvSpPr>
-          <p:cNvPr id="849" name="Rectangle 9"/>
+          <p:cNvPr id="856" name="Rectangle 9"/>
           <p:cNvSpPr/>
           <p:nvPr/>
         </p:nvSpPr>
@@ -32474,7 +32815,7 @@
       </p:sp>
       <p:sp>
         <p:nvSpPr>
-          <p:cNvPr id="850" name="Rectangle 10"/>
+          <p:cNvPr id="857" name="Rectangle 10"/>
           <p:cNvSpPr/>
           <p:nvPr/>
         </p:nvSpPr>
@@ -32532,7 +32873,7 @@
       </p:sp>
       <p:sp>
         <p:nvSpPr>
-          <p:cNvPr id="851" name="Rectangle 11"/>
+          <p:cNvPr id="858" name="Rectangle 11"/>
           <p:cNvSpPr/>
           <p:nvPr/>
         </p:nvSpPr>
@@ -32579,7 +32920,7 @@
       </p:sp>
       <p:sp>
         <p:nvSpPr>
-          <p:cNvPr id="852" name="Oval 12"/>
+          <p:cNvPr id="859" name="Oval 12"/>
           <p:cNvSpPr/>
           <p:nvPr/>
         </p:nvSpPr>
@@ -32639,7 +32980,7 @@
       </p:sp>
       <p:sp>
         <p:nvSpPr>
-          <p:cNvPr id="853" name="Rectangle 13"/>
+          <p:cNvPr id="860" name="Rectangle 13"/>
           <p:cNvSpPr/>
           <p:nvPr/>
         </p:nvSpPr>
@@ -32697,7 +33038,7 @@
       </p:sp>
       <p:sp>
         <p:nvSpPr>
-          <p:cNvPr id="854" name="Rectangle 14"/>
+          <p:cNvPr id="861" name="Rectangle 14"/>
           <p:cNvSpPr/>
           <p:nvPr/>
         </p:nvSpPr>
@@ -32744,7 +33085,7 @@
       </p:sp>
       <p:sp>
         <p:nvSpPr>
-          <p:cNvPr id="855" name="Oval 15"/>
+          <p:cNvPr id="862" name="Oval 15"/>
           <p:cNvSpPr/>
           <p:nvPr/>
         </p:nvSpPr>
@@ -32804,7 +33145,7 @@
       </p:sp>
       <p:sp>
         <p:nvSpPr>
-          <p:cNvPr id="856" name="Rectangle 16"/>
+          <p:cNvPr id="863" name="Rectangle 16"/>
           <p:cNvSpPr/>
           <p:nvPr/>
         </p:nvSpPr>
@@ -32862,7 +33203,7 @@
       </p:sp>
       <p:sp>
         <p:nvSpPr>
-          <p:cNvPr id="857" name="Rectangle 17"/>
+          <p:cNvPr id="864" name="Rectangle 17"/>
           <p:cNvSpPr/>
           <p:nvPr/>
         </p:nvSpPr>
@@ -32909,7 +33250,7 @@
       </p:sp>
       <p:sp>
         <p:nvSpPr>
-          <p:cNvPr id="858" name="Oval 18"/>
+          <p:cNvPr id="865" name="Oval 18"/>
           <p:cNvSpPr/>
           <p:nvPr/>
         </p:nvSpPr>
@@ -32969,7 +33310,7 @@
       </p:sp>
       <p:sp>
         <p:nvSpPr>
-          <p:cNvPr id="859" name="Rectangle 19"/>
+          <p:cNvPr id="866" name="Rectangle 19"/>
           <p:cNvSpPr/>
           <p:nvPr/>
         </p:nvSpPr>
@@ -33027,7 +33368,7 @@
       </p:sp>
       <p:sp>
         <p:nvSpPr>
-          <p:cNvPr id="860" name="Picture"/>
+          <p:cNvPr id="867" name="Picture"/>
           <p:cNvSpPr/>
           <p:nvPr/>
         </p:nvSpPr>
@@ -33146,7 +33487,7 @@
       </p:sp>
       <p:sp>
         <p:nvSpPr>
-          <p:cNvPr id="861" name="Rectangle 21"/>
+          <p:cNvPr id="868" name="Rectangle 21"/>
           <p:cNvSpPr/>
           <p:nvPr/>
         </p:nvSpPr>
@@ -33204,7 +33545,7 @@
       </p:sp>
       <p:sp>
         <p:nvSpPr>
-          <p:cNvPr id="862" name="Rectangle 22"/>
+          <p:cNvPr id="869" name="Rectangle 22"/>
           <p:cNvSpPr/>
           <p:nvPr/>
         </p:nvSpPr>
@@ -33249,7 +33590,7 @@
       </p:sp>
       <p:sp>
         <p:nvSpPr>
-          <p:cNvPr id="863" name="Document"/>
+          <p:cNvPr id="870" name="Document"/>
           <p:cNvSpPr/>
           <p:nvPr/>
         </p:nvSpPr>
@@ -33367,7 +33708,7 @@
       </p:sp>
       <p:sp>
         <p:nvSpPr>
-          <p:cNvPr id="864" name="Rectangle 24"/>
+          <p:cNvPr id="871" name="Rectangle 24"/>
           <p:cNvSpPr/>
           <p:nvPr/>
         </p:nvSpPr>
@@ -33425,7 +33766,7 @@
       </p:sp>
       <p:sp>
         <p:nvSpPr>
-          <p:cNvPr id="1149" name="Slide Number Placeholder"/>
+          <p:cNvPr id="1156" name="Slide Number Placeholder"/>
           <p:cNvSpPr>
             <a:spLocks noGrp="1"/>
           </p:cNvSpPr>
@@ -33472,7 +33813,7 @@
       </p:grpSpPr>
       <p:sp>
         <p:nvSpPr>
-          <p:cNvPr id="866" name="Rectangle 1"/>
+          <p:cNvPr id="873" name="Rectangle 1"/>
           <p:cNvSpPr/>
           <p:nvPr/>
         </p:nvSpPr>
@@ -33517,7 +33858,7 @@
       </p:sp>
       <p:sp>
         <p:nvSpPr>
-          <p:cNvPr id="867" name="Rectangle 2"/>
+          <p:cNvPr id="874" name="Rectangle 2"/>
           <p:cNvSpPr/>
           <p:nvPr/>
         </p:nvSpPr>
@@ -33575,7 +33916,7 @@
       </p:sp>
       <p:sp>
         <p:nvSpPr>
-          <p:cNvPr id="868" name="Rectangle 3"/>
+          <p:cNvPr id="875" name="Rectangle 3"/>
           <p:cNvSpPr/>
           <p:nvPr/>
         </p:nvSpPr>
@@ -33635,7 +33976,7 @@
       </p:sp>
       <p:sp>
         <p:nvSpPr>
-          <p:cNvPr id="869" name="Rectangle 4"/>
+          <p:cNvPr id="876" name="Rectangle 4"/>
           <p:cNvSpPr/>
           <p:nvPr/>
         </p:nvSpPr>
@@ -33693,7 +34034,7 @@
       </p:sp>
       <p:sp>
         <p:nvSpPr>
-          <p:cNvPr id="870" name="Rectangle 5"/>
+          <p:cNvPr id="877" name="Rectangle 5"/>
           <p:cNvSpPr/>
           <p:nvPr/>
         </p:nvSpPr>
@@ -33751,7 +34092,7 @@
       </p:sp>
       <p:sp>
         <p:nvSpPr>
-          <p:cNvPr id="871" name="Rectangle 6"/>
+          <p:cNvPr id="878" name="Rectangle 6"/>
           <p:cNvSpPr/>
           <p:nvPr/>
         </p:nvSpPr>
@@ -33796,7 +34137,7 @@
       </p:sp>
       <p:sp>
         <p:nvSpPr>
-          <p:cNvPr id="872" name="Rectangle 7"/>
+          <p:cNvPr id="879" name="Rectangle 7"/>
           <p:cNvSpPr/>
           <p:nvPr/>
         </p:nvSpPr>
@@ -33854,7 +34195,7 @@
       </p:sp>
       <p:sp>
         <p:nvSpPr>
-          <p:cNvPr id="873" name="Rectangle 8"/>
+          <p:cNvPr id="880" name="Rectangle 8"/>
           <p:cNvSpPr/>
           <p:nvPr/>
         </p:nvSpPr>
@@ -33912,7 +34253,7 @@
       </p:sp>
       <p:sp>
         <p:nvSpPr>
-          <p:cNvPr id="874" name="Rectangle 9"/>
+          <p:cNvPr id="881" name="Rectangle 9"/>
           <p:cNvSpPr/>
           <p:nvPr/>
         </p:nvSpPr>
@@ -33970,7 +34311,7 @@
       </p:sp>
       <p:sp>
         <p:nvSpPr>
-          <p:cNvPr id="875" name="Rectangle 10"/>
+          <p:cNvPr id="882" name="Rectangle 10"/>
           <p:cNvSpPr/>
           <p:nvPr/>
         </p:nvSpPr>
@@ -34028,7 +34369,7 @@
       </p:sp>
       <p:sp>
         <p:nvSpPr>
-          <p:cNvPr id="876" name="Rectangle 11"/>
+          <p:cNvPr id="883" name="Rectangle 11"/>
           <p:cNvSpPr/>
           <p:nvPr/>
         </p:nvSpPr>
@@ -34075,7 +34416,7 @@
       </p:sp>
       <p:sp>
         <p:nvSpPr>
-          <p:cNvPr id="877" name="Oval 12"/>
+          <p:cNvPr id="884" name="Oval 12"/>
           <p:cNvSpPr/>
           <p:nvPr/>
         </p:nvSpPr>
@@ -34135,7 +34476,7 @@
       </p:sp>
       <p:sp>
         <p:nvSpPr>
-          <p:cNvPr id="878" name="Rectangle 13"/>
+          <p:cNvPr id="885" name="Rectangle 13"/>
           <p:cNvSpPr/>
           <p:nvPr/>
         </p:nvSpPr>
@@ -34193,7 +34534,7 @@
       </p:sp>
       <p:sp>
         <p:nvSpPr>
-          <p:cNvPr id="879" name="Rectangle 14"/>
+          <p:cNvPr id="886" name="Rectangle 14"/>
           <p:cNvSpPr/>
           <p:nvPr/>
         </p:nvSpPr>
@@ -34240,7 +34581,7 @@
       </p:sp>
       <p:sp>
         <p:nvSpPr>
-          <p:cNvPr id="880" name="Oval 15"/>
+          <p:cNvPr id="887" name="Oval 15"/>
           <p:cNvSpPr/>
           <p:nvPr/>
         </p:nvSpPr>
@@ -34300,7 +34641,7 @@
       </p:sp>
       <p:sp>
         <p:nvSpPr>
-          <p:cNvPr id="881" name="Rectangle 16"/>
+          <p:cNvPr id="888" name="Rectangle 16"/>
           <p:cNvSpPr/>
           <p:nvPr/>
         </p:nvSpPr>
@@ -34358,7 +34699,7 @@
       </p:sp>
       <p:sp>
         <p:nvSpPr>
-          <p:cNvPr id="882" name="Rectangle 17"/>
+          <p:cNvPr id="889" name="Rectangle 17"/>
           <p:cNvSpPr/>
           <p:nvPr/>
         </p:nvSpPr>
@@ -34405,7 +34746,7 @@
       </p:sp>
       <p:sp>
         <p:nvSpPr>
-          <p:cNvPr id="883" name="Oval 18"/>
+          <p:cNvPr id="890" name="Oval 18"/>
           <p:cNvSpPr/>
           <p:nvPr/>
         </p:nvSpPr>
@@ -34465,7 +34806,7 @@
       </p:sp>
       <p:sp>
         <p:nvSpPr>
-          <p:cNvPr id="884" name="Rectangle 19"/>
+          <p:cNvPr id="891" name="Rectangle 19"/>
           <p:cNvSpPr/>
           <p:nvPr/>
         </p:nvSpPr>
@@ -34523,7 +34864,7 @@
       </p:sp>
       <p:sp>
         <p:nvSpPr>
-          <p:cNvPr id="885" name="Picture"/>
+          <p:cNvPr id="892" name="Picture"/>
           <p:cNvSpPr/>
           <p:nvPr/>
         </p:nvSpPr>
@@ -34642,7 +34983,7 @@
       </p:sp>
       <p:sp>
         <p:nvSpPr>
-          <p:cNvPr id="886" name="Rectangle 21"/>
+          <p:cNvPr id="893" name="Rectangle 21"/>
           <p:cNvSpPr/>
           <p:nvPr/>
         </p:nvSpPr>
@@ -34700,7 +35041,7 @@
       </p:sp>
       <p:sp>
         <p:nvSpPr>
-          <p:cNvPr id="887" name="Rectangle 22"/>
+          <p:cNvPr id="894" name="Rectangle 22"/>
           <p:cNvSpPr/>
           <p:nvPr/>
         </p:nvSpPr>
@@ -34745,7 +35086,7 @@
       </p:sp>
       <p:sp>
         <p:nvSpPr>
-          <p:cNvPr id="888" name="Document"/>
+          <p:cNvPr id="895" name="Document"/>
           <p:cNvSpPr/>
           <p:nvPr/>
         </p:nvSpPr>
@@ -34863,7 +35204,7 @@
       </p:sp>
       <p:sp>
         <p:nvSpPr>
-          <p:cNvPr id="889" name="Rectangle 24"/>
+          <p:cNvPr id="896" name="Rectangle 24"/>
           <p:cNvSpPr/>
           <p:nvPr/>
         </p:nvSpPr>
@@ -34921,7 +35262,7 @@
       </p:sp>
       <p:sp>
         <p:nvSpPr>
-          <p:cNvPr id="1152" name="Slide Number Placeholder"/>
+          <p:cNvPr id="1159" name="Slide Number Placeholder"/>
           <p:cNvSpPr>
             <a:spLocks noGrp="1"/>
           </p:cNvSpPr>
@@ -34968,7 +35309,7 @@
       </p:grpSpPr>
       <p:sp>
         <p:nvSpPr>
-          <p:cNvPr id="891" name="Rectangle 1"/>
+          <p:cNvPr id="898" name="Rectangle 1"/>
           <p:cNvSpPr/>
           <p:nvPr/>
         </p:nvSpPr>
@@ -35013,7 +35354,7 @@
       </p:sp>
       <p:sp>
         <p:nvSpPr>
-          <p:cNvPr id="892" name="Rectangle 2"/>
+          <p:cNvPr id="899" name="Rectangle 2"/>
           <p:cNvSpPr/>
           <p:nvPr/>
         </p:nvSpPr>
@@ -35071,7 +35412,7 @@
       </p:sp>
       <p:sp>
         <p:nvSpPr>
-          <p:cNvPr id="893" name="Rectangle 3"/>
+          <p:cNvPr id="900" name="Rectangle 3"/>
           <p:cNvSpPr/>
           <p:nvPr/>
         </p:nvSpPr>
@@ -35131,7 +35472,7 @@
       </p:sp>
       <p:sp>
         <p:nvSpPr>
-          <p:cNvPr id="894" name="Rectangle 4"/>
+          <p:cNvPr id="901" name="Rectangle 4"/>
           <p:cNvSpPr/>
           <p:nvPr/>
         </p:nvSpPr>
@@ -35189,7 +35530,7 @@
       </p:sp>
       <p:sp>
         <p:nvSpPr>
-          <p:cNvPr id="895" name="Rectangle 5"/>
+          <p:cNvPr id="902" name="Rectangle 5"/>
           <p:cNvSpPr/>
           <p:nvPr/>
         </p:nvSpPr>
@@ -35247,7 +35588,7 @@
       </p:sp>
       <p:sp>
         <p:nvSpPr>
-          <p:cNvPr id="896" name="Rectangle 6"/>
+          <p:cNvPr id="903" name="Rectangle 6"/>
           <p:cNvSpPr/>
           <p:nvPr/>
         </p:nvSpPr>
@@ -35292,7 +35633,7 @@
       </p:sp>
       <p:sp>
         <p:nvSpPr>
-          <p:cNvPr id="897" name="Rectangle 7"/>
+          <p:cNvPr id="904" name="Rectangle 7"/>
           <p:cNvSpPr/>
           <p:nvPr/>
         </p:nvSpPr>
@@ -35350,7 +35691,7 @@
       </p:sp>
       <p:sp>
         <p:nvSpPr>
-          <p:cNvPr id="898" name="Rectangle 8"/>
+          <p:cNvPr id="905" name="Rectangle 8"/>
           <p:cNvSpPr/>
           <p:nvPr/>
         </p:nvSpPr>
@@ -35408,7 +35749,7 @@
       </p:sp>
       <p:sp>
         <p:nvSpPr>
-          <p:cNvPr id="899" name="Rectangle 9"/>
+          <p:cNvPr id="906" name="Rectangle 9"/>
           <p:cNvSpPr/>
           <p:nvPr/>
         </p:nvSpPr>
@@ -35466,7 +35807,7 @@
       </p:sp>
       <p:sp>
         <p:nvSpPr>
-          <p:cNvPr id="900" name="Rectangle 10"/>
+          <p:cNvPr id="907" name="Rectangle 10"/>
           <p:cNvSpPr/>
           <p:nvPr/>
         </p:nvSpPr>
@@ -35524,7 +35865,7 @@
       </p:sp>
       <p:sp>
         <p:nvSpPr>
-          <p:cNvPr id="901" name="Rectangle 11"/>
+          <p:cNvPr id="908" name="Rectangle 11"/>
           <p:cNvSpPr/>
           <p:nvPr/>
         </p:nvSpPr>
@@ -35571,7 +35912,7 @@
       </p:sp>
       <p:sp>
         <p:nvSpPr>
-          <p:cNvPr id="902" name="Oval 12"/>
+          <p:cNvPr id="909" name="Oval 12"/>
           <p:cNvSpPr/>
           <p:nvPr/>
         </p:nvSpPr>
@@ -35631,7 +35972,7 @@
       </p:sp>
       <p:sp>
         <p:nvSpPr>
-          <p:cNvPr id="903" name="Rectangle 13"/>
+          <p:cNvPr id="910" name="Rectangle 13"/>
           <p:cNvSpPr/>
           <p:nvPr/>
         </p:nvSpPr>
@@ -35689,7 +36030,7 @@
       </p:sp>
       <p:sp>
         <p:nvSpPr>
-          <p:cNvPr id="904" name="Rectangle 14"/>
+          <p:cNvPr id="911" name="Rectangle 14"/>
           <p:cNvSpPr/>
           <p:nvPr/>
         </p:nvSpPr>
@@ -35736,7 +36077,7 @@
       </p:sp>
       <p:sp>
         <p:nvSpPr>
-          <p:cNvPr id="905" name="Oval 15"/>
+          <p:cNvPr id="912" name="Oval 15"/>
           <p:cNvSpPr/>
           <p:nvPr/>
         </p:nvSpPr>
@@ -35796,7 +36137,7 @@
       </p:sp>
       <p:sp>
         <p:nvSpPr>
-          <p:cNvPr id="906" name="Rectangle 16"/>
+          <p:cNvPr id="913" name="Rectangle 16"/>
           <p:cNvSpPr/>
           <p:nvPr/>
         </p:nvSpPr>
@@ -35854,7 +36195,7 @@
       </p:sp>
       <p:sp>
         <p:nvSpPr>
-          <p:cNvPr id="907" name="Picture"/>
+          <p:cNvPr id="914" name="Picture"/>
           <p:cNvSpPr/>
           <p:nvPr/>
         </p:nvSpPr>
@@ -35973,7 +36314,7 @@
       </p:sp>
       <p:sp>
         <p:nvSpPr>
-          <p:cNvPr id="908" name="Rectangle 18"/>
+          <p:cNvPr id="915" name="Rectangle 18"/>
           <p:cNvSpPr/>
           <p:nvPr/>
         </p:nvSpPr>
@@ -36031,7 +36372,7 @@
       </p:sp>
       <p:sp>
         <p:nvSpPr>
-          <p:cNvPr id="909" name="Rectangle 19"/>
+          <p:cNvPr id="916" name="Rectangle 19"/>
           <p:cNvSpPr/>
           <p:nvPr/>
         </p:nvSpPr>
@@ -36076,7 +36417,7 @@
       </p:sp>
       <p:sp>
         <p:nvSpPr>
-          <p:cNvPr id="910" name="Document"/>
+          <p:cNvPr id="917" name="Document"/>
           <p:cNvSpPr/>
           <p:nvPr/>
         </p:nvSpPr>
@@ -36194,7 +36535,7 @@
       </p:sp>
       <p:sp>
         <p:nvSpPr>
-          <p:cNvPr id="911" name="Rectangle 21"/>
+          <p:cNvPr id="918" name="Rectangle 21"/>
           <p:cNvSpPr/>
           <p:nvPr/>
         </p:nvSpPr>
@@ -36252,7 +36593,7 @@
       </p:sp>
       <p:sp>
         <p:nvSpPr>
-          <p:cNvPr id="1155" name="Slide Number Placeholder"/>
+          <p:cNvPr id="1162" name="Slide Number Placeholder"/>
           <p:cNvSpPr>
             <a:spLocks noGrp="1"/>
           </p:cNvSpPr>
@@ -36299,7 +36640,7 @@
       </p:grpSpPr>
       <p:sp>
         <p:nvSpPr>
-          <p:cNvPr id="913" name="Rectangle 1"/>
+          <p:cNvPr id="920" name="Rectangle 1"/>
           <p:cNvSpPr/>
           <p:nvPr/>
         </p:nvSpPr>
@@ -36344,7 +36685,7 @@
       </p:sp>
       <p:sp>
         <p:nvSpPr>
-          <p:cNvPr id="914" name="Rectangle 2"/>
+          <p:cNvPr id="921" name="Rectangle 2"/>
           <p:cNvSpPr/>
           <p:nvPr/>
         </p:nvSpPr>
@@ -36402,7 +36743,7 @@
       </p:sp>
       <p:sp>
         <p:nvSpPr>
-          <p:cNvPr id="915" name="Rectangle 3"/>
+          <p:cNvPr id="922" name="Rectangle 3"/>
           <p:cNvSpPr/>
           <p:nvPr/>
         </p:nvSpPr>
@@ -36462,7 +36803,7 @@
       </p:sp>
       <p:sp>
         <p:nvSpPr>
-          <p:cNvPr id="916" name="Rectangle 4"/>
+          <p:cNvPr id="923" name="Rectangle 4"/>
           <p:cNvSpPr/>
           <p:nvPr/>
         </p:nvSpPr>
@@ -36520,7 +36861,7 @@
       </p:sp>
       <p:sp>
         <p:nvSpPr>
-          <p:cNvPr id="917" name="Rectangle 5"/>
+          <p:cNvPr id="924" name="Rectangle 5"/>
           <p:cNvSpPr/>
           <p:nvPr/>
         </p:nvSpPr>
@@ -36578,7 +36919,7 @@
       </p:sp>
       <p:sp>
         <p:nvSpPr>
-          <p:cNvPr id="918" name="Rectangle 6"/>
+          <p:cNvPr id="925" name="Rectangle 6"/>
           <p:cNvSpPr/>
           <p:nvPr/>
         </p:nvSpPr>
@@ -36623,7 +36964,7 @@
       </p:sp>
       <p:sp>
         <p:nvSpPr>
-          <p:cNvPr id="919" name="Rectangle 7"/>
+          <p:cNvPr id="926" name="Rectangle 7"/>
           <p:cNvSpPr/>
           <p:nvPr/>
         </p:nvSpPr>
@@ -36681,7 +37022,7 @@
       </p:sp>
       <p:sp>
         <p:nvSpPr>
-          <p:cNvPr id="920" name="Rectangle 8"/>
+          <p:cNvPr id="927" name="Rectangle 8"/>
           <p:cNvSpPr/>
           <p:nvPr/>
         </p:nvSpPr>
@@ -36739,7 +37080,7 @@
       </p:sp>
       <p:sp>
         <p:nvSpPr>
-          <p:cNvPr id="921" name="Rectangle 9"/>
+          <p:cNvPr id="928" name="Rectangle 9"/>
           <p:cNvSpPr/>
           <p:nvPr/>
         </p:nvSpPr>
@@ -36797,7 +37138,7 @@
       </p:sp>
       <p:sp>
         <p:nvSpPr>
-          <p:cNvPr id="922" name="Rectangle 10"/>
+          <p:cNvPr id="929" name="Rectangle 10"/>
           <p:cNvSpPr/>
           <p:nvPr/>
         </p:nvSpPr>
@@ -36855,7 +37196,7 @@
       </p:sp>
       <p:sp>
         <p:nvSpPr>
-          <p:cNvPr id="923" name="Rectangle 11"/>
+          <p:cNvPr id="930" name="Rectangle 11"/>
           <p:cNvSpPr/>
           <p:nvPr/>
         </p:nvSpPr>
@@ -36902,7 +37243,7 @@
       </p:sp>
       <p:sp>
         <p:nvSpPr>
-          <p:cNvPr id="924" name="Oval 12"/>
+          <p:cNvPr id="931" name="Oval 12"/>
           <p:cNvSpPr/>
           <p:nvPr/>
         </p:nvSpPr>
@@ -36962,7 +37303,7 @@
       </p:sp>
       <p:sp>
         <p:nvSpPr>
-          <p:cNvPr id="925" name="Rectangle 13"/>
+          <p:cNvPr id="932" name="Rectangle 13"/>
           <p:cNvSpPr/>
           <p:nvPr/>
         </p:nvSpPr>
@@ -37020,7 +37361,7 @@
       </p:sp>
       <p:sp>
         <p:nvSpPr>
-          <p:cNvPr id="926" name="Rectangle 14"/>
+          <p:cNvPr id="933" name="Rectangle 14"/>
           <p:cNvSpPr/>
           <p:nvPr/>
         </p:nvSpPr>
@@ -37067,7 +37408,7 @@
       </p:sp>
       <p:sp>
         <p:nvSpPr>
-          <p:cNvPr id="927" name="Oval 15"/>
+          <p:cNvPr id="934" name="Oval 15"/>
           <p:cNvSpPr/>
           <p:nvPr/>
         </p:nvSpPr>
@@ -37127,7 +37468,7 @@
       </p:sp>
       <p:sp>
         <p:nvSpPr>
-          <p:cNvPr id="928" name="Rectangle 16"/>
+          <p:cNvPr id="935" name="Rectangle 16"/>
           <p:cNvSpPr/>
           <p:nvPr/>
         </p:nvSpPr>
@@ -37185,7 +37526,7 @@
       </p:sp>
       <p:sp>
         <p:nvSpPr>
-          <p:cNvPr id="929" name="Picture"/>
+          <p:cNvPr id="936" name="Picture"/>
           <p:cNvSpPr/>
           <p:nvPr/>
         </p:nvSpPr>
@@ -37304,7 +37645,7 @@
       </p:sp>
       <p:sp>
         <p:nvSpPr>
-          <p:cNvPr id="930" name="Rectangle 18"/>
+          <p:cNvPr id="937" name="Rectangle 18"/>
           <p:cNvSpPr/>
           <p:nvPr/>
         </p:nvSpPr>
@@ -37362,7 +37703,7 @@
       </p:sp>
       <p:sp>
         <p:nvSpPr>
-          <p:cNvPr id="931" name="Rectangle 19"/>
+          <p:cNvPr id="938" name="Rectangle 19"/>
           <p:cNvSpPr/>
           <p:nvPr/>
         </p:nvSpPr>
@@ -37407,7 +37748,7 @@
       </p:sp>
       <p:sp>
         <p:nvSpPr>
-          <p:cNvPr id="932" name="Document"/>
+          <p:cNvPr id="939" name="Document"/>
           <p:cNvSpPr/>
           <p:nvPr/>
         </p:nvSpPr>
@@ -37525,7 +37866,7 @@
       </p:sp>
       <p:sp>
         <p:nvSpPr>
-          <p:cNvPr id="933" name="Rectangle 21"/>
+          <p:cNvPr id="940" name="Rectangle 21"/>
           <p:cNvSpPr/>
           <p:nvPr/>
         </p:nvSpPr>
@@ -37583,7 +37924,7 @@
       </p:sp>
       <p:sp>
         <p:nvSpPr>
-          <p:cNvPr id="1158" name="Slide Number Placeholder"/>
+          <p:cNvPr id="1165" name="Slide Number Placeholder"/>
           <p:cNvSpPr>
             <a:spLocks noGrp="1"/>
           </p:cNvSpPr>
@@ -38023,7 +38364,7 @@
       </p:sp>
       <p:sp>
         <p:nvSpPr>
-          <p:cNvPr id="1053" name="Slide Number Placeholder"/>
+          <p:cNvPr id="1060" name="Slide Number Placeholder"/>
           <p:cNvSpPr>
             <a:spLocks noGrp="1"/>
           </p:cNvSpPr>
@@ -38070,7 +38411,7 @@
       </p:grpSpPr>
       <p:sp>
         <p:nvSpPr>
-          <p:cNvPr id="935" name="Rectangle 1"/>
+          <p:cNvPr id="942" name="Rectangle 1"/>
           <p:cNvSpPr/>
           <p:nvPr/>
         </p:nvSpPr>
@@ -38115,7 +38456,7 @@
       </p:sp>
       <p:sp>
         <p:nvSpPr>
-          <p:cNvPr id="936" name="Rectangle 2"/>
+          <p:cNvPr id="943" name="Rectangle 2"/>
           <p:cNvSpPr/>
           <p:nvPr/>
         </p:nvSpPr>
@@ -38173,7 +38514,7 @@
       </p:sp>
       <p:sp>
         <p:nvSpPr>
-          <p:cNvPr id="937" name="Rectangle 3"/>
+          <p:cNvPr id="944" name="Rectangle 3"/>
           <p:cNvSpPr/>
           <p:nvPr/>
         </p:nvSpPr>
@@ -38233,7 +38574,7 @@
       </p:sp>
       <p:sp>
         <p:nvSpPr>
-          <p:cNvPr id="938" name="Rectangle 4"/>
+          <p:cNvPr id="945" name="Rectangle 4"/>
           <p:cNvSpPr/>
           <p:nvPr/>
         </p:nvSpPr>
@@ -38291,7 +38632,7 @@
       </p:sp>
       <p:sp>
         <p:nvSpPr>
-          <p:cNvPr id="939" name="Rectangle 5"/>
+          <p:cNvPr id="946" name="Rectangle 5"/>
           <p:cNvSpPr/>
           <p:nvPr/>
         </p:nvSpPr>
@@ -38349,7 +38690,7 @@
       </p:sp>
       <p:sp>
         <p:nvSpPr>
-          <p:cNvPr id="940" name="Rectangle 6"/>
+          <p:cNvPr id="947" name="Rectangle 6"/>
           <p:cNvSpPr/>
           <p:nvPr/>
         </p:nvSpPr>
@@ -38394,7 +38735,7 @@
       </p:sp>
       <p:sp>
         <p:nvSpPr>
-          <p:cNvPr id="941" name="Rectangle 7"/>
+          <p:cNvPr id="948" name="Rectangle 7"/>
           <p:cNvSpPr/>
           <p:nvPr/>
         </p:nvSpPr>
@@ -38452,7 +38793,7 @@
       </p:sp>
       <p:sp>
         <p:nvSpPr>
-          <p:cNvPr id="942" name="Rectangle 8"/>
+          <p:cNvPr id="949" name="Rectangle 8"/>
           <p:cNvSpPr/>
           <p:nvPr/>
         </p:nvSpPr>
@@ -38510,7 +38851,7 @@
       </p:sp>
       <p:sp>
         <p:nvSpPr>
-          <p:cNvPr id="943" name="Rectangle 9"/>
+          <p:cNvPr id="950" name="Rectangle 9"/>
           <p:cNvSpPr/>
           <p:nvPr/>
         </p:nvSpPr>
@@ -38568,7 +38909,7 @@
       </p:sp>
       <p:sp>
         <p:nvSpPr>
-          <p:cNvPr id="944" name="Rectangle 10"/>
+          <p:cNvPr id="951" name="Rectangle 10"/>
           <p:cNvSpPr/>
           <p:nvPr/>
         </p:nvSpPr>
@@ -38626,7 +38967,7 @@
       </p:sp>
       <p:sp>
         <p:nvSpPr>
-          <p:cNvPr id="945" name="Rectangle 11"/>
+          <p:cNvPr id="952" name="Rectangle 11"/>
           <p:cNvSpPr/>
           <p:nvPr/>
         </p:nvSpPr>
@@ -38673,7 +39014,7 @@
       </p:sp>
       <p:sp>
         <p:nvSpPr>
-          <p:cNvPr id="946" name="Oval 12"/>
+          <p:cNvPr id="953" name="Oval 12"/>
           <p:cNvSpPr/>
           <p:nvPr/>
         </p:nvSpPr>
@@ -38733,7 +39074,7 @@
       </p:sp>
       <p:sp>
         <p:nvSpPr>
-          <p:cNvPr id="947" name="Rectangle 13"/>
+          <p:cNvPr id="954" name="Rectangle 13"/>
           <p:cNvSpPr/>
           <p:nvPr/>
         </p:nvSpPr>
@@ -38791,7 +39132,7 @@
       </p:sp>
       <p:sp>
         <p:nvSpPr>
-          <p:cNvPr id="948" name="Rectangle 14"/>
+          <p:cNvPr id="955" name="Rectangle 14"/>
           <p:cNvSpPr/>
           <p:nvPr/>
         </p:nvSpPr>
@@ -38838,7 +39179,7 @@
       </p:sp>
       <p:sp>
         <p:nvSpPr>
-          <p:cNvPr id="949" name="Oval 15"/>
+          <p:cNvPr id="956" name="Oval 15"/>
           <p:cNvSpPr/>
           <p:nvPr/>
         </p:nvSpPr>
@@ -38898,7 +39239,7 @@
       </p:sp>
       <p:sp>
         <p:nvSpPr>
-          <p:cNvPr id="950" name="Rectangle 16"/>
+          <p:cNvPr id="957" name="Rectangle 16"/>
           <p:cNvSpPr/>
           <p:nvPr/>
         </p:nvSpPr>
@@ -38956,7 +39297,7 @@
       </p:sp>
       <p:sp>
         <p:nvSpPr>
-          <p:cNvPr id="951" name="Picture"/>
+          <p:cNvPr id="958" name="Picture"/>
           <p:cNvSpPr/>
           <p:nvPr/>
         </p:nvSpPr>
@@ -39075,7 +39416,7 @@
       </p:sp>
       <p:sp>
         <p:nvSpPr>
-          <p:cNvPr id="952" name="Rectangle 18"/>
+          <p:cNvPr id="959" name="Rectangle 18"/>
           <p:cNvSpPr/>
           <p:nvPr/>
         </p:nvSpPr>
@@ -39133,7 +39474,7 @@
       </p:sp>
       <p:sp>
         <p:nvSpPr>
-          <p:cNvPr id="953" name="Rectangle 19"/>
+          <p:cNvPr id="960" name="Rectangle 19"/>
           <p:cNvSpPr/>
           <p:nvPr/>
         </p:nvSpPr>
@@ -39178,7 +39519,7 @@
       </p:sp>
       <p:sp>
         <p:nvSpPr>
-          <p:cNvPr id="954" name="Document"/>
+          <p:cNvPr id="961" name="Document"/>
           <p:cNvSpPr/>
           <p:nvPr/>
         </p:nvSpPr>
@@ -39296,7 +39637,7 @@
       </p:sp>
       <p:sp>
         <p:nvSpPr>
-          <p:cNvPr id="955" name="Rectangle 21"/>
+          <p:cNvPr id="962" name="Rectangle 21"/>
           <p:cNvSpPr/>
           <p:nvPr/>
         </p:nvSpPr>
@@ -39354,7 +39695,7 @@
       </p:sp>
       <p:sp>
         <p:nvSpPr>
-          <p:cNvPr id="1161" name="Slide Number Placeholder"/>
+          <p:cNvPr id="1168" name="Slide Number Placeholder"/>
           <p:cNvSpPr>
             <a:spLocks noGrp="1"/>
           </p:cNvSpPr>
@@ -39401,7 +39742,7 @@
       </p:grpSpPr>
       <p:sp>
         <p:nvSpPr>
-          <p:cNvPr id="957" name="Rectangle 1"/>
+          <p:cNvPr id="964" name="Rectangle 1"/>
           <p:cNvSpPr/>
           <p:nvPr/>
         </p:nvSpPr>
@@ -39446,7 +39787,7 @@
       </p:sp>
       <p:sp>
         <p:nvSpPr>
-          <p:cNvPr id="958" name="Rectangle 2"/>
+          <p:cNvPr id="965" name="Rectangle 2"/>
           <p:cNvSpPr/>
           <p:nvPr/>
         </p:nvSpPr>
@@ -39504,7 +39845,7 @@
       </p:sp>
       <p:sp>
         <p:nvSpPr>
-          <p:cNvPr id="959" name="Rectangle 3"/>
+          <p:cNvPr id="966" name="Rectangle 3"/>
           <p:cNvSpPr/>
           <p:nvPr/>
         </p:nvSpPr>
@@ -39564,7 +39905,7 @@
       </p:sp>
       <p:sp>
         <p:nvSpPr>
-          <p:cNvPr id="960" name="Rectangle 4"/>
+          <p:cNvPr id="967" name="Rectangle 4"/>
           <p:cNvSpPr/>
           <p:nvPr/>
         </p:nvSpPr>
@@ -39622,7 +39963,7 @@
       </p:sp>
       <p:sp>
         <p:nvSpPr>
-          <p:cNvPr id="961" name="Rectangle 5"/>
+          <p:cNvPr id="968" name="Rectangle 5"/>
           <p:cNvSpPr/>
           <p:nvPr/>
         </p:nvSpPr>
@@ -39680,7 +40021,7 @@
       </p:sp>
       <p:sp>
         <p:nvSpPr>
-          <p:cNvPr id="962" name="Rectangle 6"/>
+          <p:cNvPr id="969" name="Rectangle 6"/>
           <p:cNvSpPr/>
           <p:nvPr/>
         </p:nvSpPr>
@@ -39725,7 +40066,7 @@
       </p:sp>
       <p:sp>
         <p:nvSpPr>
-          <p:cNvPr id="963" name="Rectangle 7"/>
+          <p:cNvPr id="970" name="Rectangle 7"/>
           <p:cNvSpPr/>
           <p:nvPr/>
         </p:nvSpPr>
@@ -39783,7 +40124,7 @@
       </p:sp>
       <p:sp>
         <p:nvSpPr>
-          <p:cNvPr id="964" name="Rectangle 8"/>
+          <p:cNvPr id="971" name="Rectangle 8"/>
           <p:cNvSpPr/>
           <p:nvPr/>
         </p:nvSpPr>
@@ -39841,7 +40182,7 @@
       </p:sp>
       <p:sp>
         <p:nvSpPr>
-          <p:cNvPr id="965" name="Rectangle 9"/>
+          <p:cNvPr id="972" name="Rectangle 9"/>
           <p:cNvSpPr/>
           <p:nvPr/>
         </p:nvSpPr>
@@ -39899,7 +40240,7 @@
       </p:sp>
       <p:sp>
         <p:nvSpPr>
-          <p:cNvPr id="966" name="Rectangle 10"/>
+          <p:cNvPr id="973" name="Rectangle 10"/>
           <p:cNvSpPr/>
           <p:nvPr/>
         </p:nvSpPr>
@@ -39947,7 +40288,7 @@
                   <a:srgbClr val="12384D"/>
                 </a:solidFill>
               </a:rPr>
-              <a:t>What does DBGI check today before honouring a repeat order at the special price?</a:t>
+              <a:t>What should DBGI check before honouring a repeat order at the special price (for example a purchase order, the same end-user, the same product)?</a:t>
             </a:r>
             <a:endParaRPr sz="1400" b="0">
               <a:solidFill>
@@ -39959,7 +40300,7 @@
       </p:sp>
       <p:sp>
         <p:nvSpPr>
-          <p:cNvPr id="967" name="Message"/>
+          <p:cNvPr id="974" name="Message"/>
           <p:cNvSpPr/>
           <p:nvPr/>
         </p:nvSpPr>
@@ -40053,7 +40394,7 @@
       </p:sp>
       <p:sp>
         <p:nvSpPr>
-          <p:cNvPr id="968" name="Rectangle 12"/>
+          <p:cNvPr id="975" name="Rectangle 12"/>
           <p:cNvSpPr/>
           <p:nvPr/>
         </p:nvSpPr>
@@ -40098,7 +40439,7 @@
       </p:sp>
       <p:sp>
         <p:nvSpPr>
-          <p:cNvPr id="969" name="Document"/>
+          <p:cNvPr id="976" name="Document"/>
           <p:cNvSpPr/>
           <p:nvPr/>
         </p:nvSpPr>
@@ -40216,7 +40557,7 @@
       </p:sp>
       <p:sp>
         <p:nvSpPr>
-          <p:cNvPr id="970" name="Rectangle 14"/>
+          <p:cNvPr id="977" name="Rectangle 14"/>
           <p:cNvSpPr/>
           <p:nvPr/>
         </p:nvSpPr>
@@ -40274,7 +40615,7 @@
       </p:sp>
       <p:sp>
         <p:nvSpPr>
-          <p:cNvPr id="1164" name="Slide Number Placeholder"/>
+          <p:cNvPr id="1171" name="Slide Number Placeholder"/>
           <p:cNvSpPr>
             <a:spLocks noGrp="1"/>
           </p:cNvSpPr>
@@ -40321,7 +40662,7 @@
       </p:grpSpPr>
       <p:sp>
         <p:nvSpPr>
-          <p:cNvPr id="972" name="Rectangle 1"/>
+          <p:cNvPr id="979" name="Rectangle 1"/>
           <p:cNvSpPr/>
           <p:nvPr/>
         </p:nvSpPr>
@@ -40366,7 +40707,7 @@
       </p:sp>
       <p:sp>
         <p:nvSpPr>
-          <p:cNvPr id="973" name="Rectangle 2"/>
+          <p:cNvPr id="980" name="Rectangle 2"/>
           <p:cNvSpPr/>
           <p:nvPr/>
         </p:nvSpPr>
@@ -40424,7 +40765,7 @@
       </p:sp>
       <p:sp>
         <p:nvSpPr>
-          <p:cNvPr id="974" name="Rectangle 3"/>
+          <p:cNvPr id="981" name="Rectangle 3"/>
           <p:cNvSpPr/>
           <p:nvPr/>
         </p:nvSpPr>
@@ -40484,7 +40825,7 @@
       </p:sp>
       <p:sp>
         <p:nvSpPr>
-          <p:cNvPr id="975" name="Rectangle 4"/>
+          <p:cNvPr id="982" name="Rectangle 4"/>
           <p:cNvSpPr/>
           <p:nvPr/>
         </p:nvSpPr>
@@ -40542,7 +40883,7 @@
       </p:sp>
       <p:sp>
         <p:nvSpPr>
-          <p:cNvPr id="976" name="Rectangle 5"/>
+          <p:cNvPr id="983" name="Rectangle 5"/>
           <p:cNvSpPr/>
           <p:nvPr/>
         </p:nvSpPr>
@@ -40600,7 +40941,7 @@
       </p:sp>
       <p:sp>
         <p:nvSpPr>
-          <p:cNvPr id="977" name="Rectangle 6"/>
+          <p:cNvPr id="984" name="Rectangle 6"/>
           <p:cNvSpPr/>
           <p:nvPr/>
         </p:nvSpPr>
@@ -40645,7 +40986,7 @@
       </p:sp>
       <p:sp>
         <p:nvSpPr>
-          <p:cNvPr id="978" name="Rectangle 7"/>
+          <p:cNvPr id="985" name="Rectangle 7"/>
           <p:cNvSpPr/>
           <p:nvPr/>
         </p:nvSpPr>
@@ -40703,7 +41044,7 @@
       </p:sp>
       <p:sp>
         <p:nvSpPr>
-          <p:cNvPr id="979" name="Rectangle 8"/>
+          <p:cNvPr id="986" name="Rectangle 8"/>
           <p:cNvSpPr/>
           <p:nvPr/>
         </p:nvSpPr>
@@ -40761,7 +41102,7 @@
       </p:sp>
       <p:sp>
         <p:nvSpPr>
-          <p:cNvPr id="980" name="Rectangle 9"/>
+          <p:cNvPr id="987" name="Rectangle 9"/>
           <p:cNvSpPr/>
           <p:nvPr/>
         </p:nvSpPr>
@@ -40819,7 +41160,7 @@
       </p:sp>
       <p:sp>
         <p:nvSpPr>
-          <p:cNvPr id="981" name="Rectangle 10"/>
+          <p:cNvPr id="988" name="Rectangle 10"/>
           <p:cNvSpPr/>
           <p:nvPr/>
         </p:nvSpPr>
@@ -40866,7 +41207,7 @@
       </p:sp>
       <p:sp>
         <p:nvSpPr>
-          <p:cNvPr id="982" name="Oval 11"/>
+          <p:cNvPr id="989" name="Oval 11"/>
           <p:cNvSpPr/>
           <p:nvPr/>
         </p:nvSpPr>
@@ -40926,7 +41267,7 @@
       </p:sp>
       <p:sp>
         <p:nvSpPr>
-          <p:cNvPr id="983" name="Rectangle 12"/>
+          <p:cNvPr id="990" name="Rectangle 12"/>
           <p:cNvSpPr/>
           <p:nvPr/>
         </p:nvSpPr>
@@ -40984,7 +41325,7 @@
       </p:sp>
       <p:sp>
         <p:nvSpPr>
-          <p:cNvPr id="984" name="Rectangle 13"/>
+          <p:cNvPr id="991" name="Rectangle 13"/>
           <p:cNvSpPr/>
           <p:nvPr/>
         </p:nvSpPr>
@@ -41031,7 +41372,7 @@
       </p:sp>
       <p:sp>
         <p:nvSpPr>
-          <p:cNvPr id="985" name="Oval 14"/>
+          <p:cNvPr id="992" name="Oval 14"/>
           <p:cNvSpPr/>
           <p:nvPr/>
         </p:nvSpPr>
@@ -41091,7 +41432,7 @@
       </p:sp>
       <p:sp>
         <p:nvSpPr>
-          <p:cNvPr id="986" name="Rectangle 15"/>
+          <p:cNvPr id="993" name="Rectangle 15"/>
           <p:cNvSpPr/>
           <p:nvPr/>
         </p:nvSpPr>
@@ -41149,7 +41490,7 @@
       </p:sp>
       <p:sp>
         <p:nvSpPr>
-          <p:cNvPr id="987" name="Rectangle 16"/>
+          <p:cNvPr id="994" name="Rectangle 16"/>
           <p:cNvSpPr/>
           <p:nvPr/>
         </p:nvSpPr>
@@ -41196,7 +41537,7 @@
       </p:sp>
       <p:sp>
         <p:nvSpPr>
-          <p:cNvPr id="988" name="Oval 17"/>
+          <p:cNvPr id="995" name="Oval 17"/>
           <p:cNvSpPr/>
           <p:nvPr/>
         </p:nvSpPr>
@@ -41256,7 +41597,7 @@
       </p:sp>
       <p:sp>
         <p:nvSpPr>
-          <p:cNvPr id="989" name="Rectangle 18"/>
+          <p:cNvPr id="996" name="Rectangle 18"/>
           <p:cNvSpPr/>
           <p:nvPr/>
         </p:nvSpPr>
@@ -41314,7 +41655,7 @@
       </p:sp>
       <p:sp>
         <p:nvSpPr>
-          <p:cNvPr id="990" name="Picture"/>
+          <p:cNvPr id="997" name="Picture"/>
           <p:cNvSpPr/>
           <p:nvPr/>
         </p:nvSpPr>
@@ -41433,7 +41774,7 @@
       </p:sp>
       <p:sp>
         <p:nvSpPr>
-          <p:cNvPr id="991" name="Rectangle 20"/>
+          <p:cNvPr id="998" name="Rectangle 20"/>
           <p:cNvSpPr/>
           <p:nvPr/>
         </p:nvSpPr>
@@ -41491,7 +41832,7 @@
       </p:sp>
       <p:sp>
         <p:nvSpPr>
-          <p:cNvPr id="992" name="Rectangle 21"/>
+          <p:cNvPr id="999" name="Rectangle 21"/>
           <p:cNvSpPr/>
           <p:nvPr/>
         </p:nvSpPr>
@@ -41536,7 +41877,7 @@
       </p:sp>
       <p:sp>
         <p:nvSpPr>
-          <p:cNvPr id="993" name="Document"/>
+          <p:cNvPr id="1000" name="Document"/>
           <p:cNvSpPr/>
           <p:nvPr/>
         </p:nvSpPr>
@@ -41654,7 +41995,7 @@
       </p:sp>
       <p:sp>
         <p:nvSpPr>
-          <p:cNvPr id="994" name="Rectangle 23"/>
+          <p:cNvPr id="1001" name="Rectangle 23"/>
           <p:cNvSpPr/>
           <p:nvPr/>
         </p:nvSpPr>
@@ -41712,7 +42053,7 @@
       </p:sp>
       <p:sp>
         <p:nvSpPr>
-          <p:cNvPr id="1167" name="Slide Number Placeholder"/>
+          <p:cNvPr id="1174" name="Slide Number Placeholder"/>
           <p:cNvSpPr>
             <a:spLocks noGrp="1"/>
           </p:cNvSpPr>
@@ -41759,7 +42100,7 @@
       </p:grpSpPr>
       <p:sp>
         <p:nvSpPr>
-          <p:cNvPr id="996" name="Rectangle 1"/>
+          <p:cNvPr id="1003" name="Rectangle 1"/>
           <p:cNvSpPr/>
           <p:nvPr/>
         </p:nvSpPr>
@@ -41804,7 +42145,7 @@
       </p:sp>
       <p:sp>
         <p:nvSpPr>
-          <p:cNvPr id="997" name="Rectangle 2"/>
+          <p:cNvPr id="1004" name="Rectangle 2"/>
           <p:cNvSpPr/>
           <p:nvPr/>
         </p:nvSpPr>
@@ -41862,7 +42203,7 @@
       </p:sp>
       <p:sp>
         <p:nvSpPr>
-          <p:cNvPr id="998" name="Rectangle 3"/>
+          <p:cNvPr id="1005" name="Rectangle 3"/>
           <p:cNvSpPr/>
           <p:nvPr/>
         </p:nvSpPr>
@@ -41922,7 +42263,7 @@
       </p:sp>
       <p:sp>
         <p:nvSpPr>
-          <p:cNvPr id="999" name="Rectangle 4"/>
+          <p:cNvPr id="1006" name="Rectangle 4"/>
           <p:cNvSpPr/>
           <p:nvPr/>
         </p:nvSpPr>
@@ -41980,7 +42321,7 @@
       </p:sp>
       <p:sp>
         <p:nvSpPr>
-          <p:cNvPr id="1000" name="Rectangle 5"/>
+          <p:cNvPr id="1007" name="Rectangle 5"/>
           <p:cNvSpPr/>
           <p:nvPr/>
         </p:nvSpPr>
@@ -42038,7 +42379,7 @@
       </p:sp>
       <p:sp>
         <p:nvSpPr>
-          <p:cNvPr id="1001" name="Rectangle 6"/>
+          <p:cNvPr id="1008" name="Rectangle 6"/>
           <p:cNvSpPr/>
           <p:nvPr/>
         </p:nvSpPr>
@@ -42083,7 +42424,7 @@
       </p:sp>
       <p:sp>
         <p:nvSpPr>
-          <p:cNvPr id="1002" name="Rectangle 7"/>
+          <p:cNvPr id="1009" name="Rectangle 7"/>
           <p:cNvSpPr/>
           <p:nvPr/>
         </p:nvSpPr>
@@ -42141,7 +42482,7 @@
       </p:sp>
       <p:sp>
         <p:nvSpPr>
-          <p:cNvPr id="1003" name="Rectangle 8"/>
+          <p:cNvPr id="1010" name="Rectangle 8"/>
           <p:cNvSpPr/>
           <p:nvPr/>
         </p:nvSpPr>
@@ -42199,7 +42540,7 @@
       </p:sp>
       <p:sp>
         <p:nvSpPr>
-          <p:cNvPr id="1004" name="Rectangle 9"/>
+          <p:cNvPr id="1011" name="Rectangle 9"/>
           <p:cNvSpPr/>
           <p:nvPr/>
         </p:nvSpPr>
@@ -42257,7 +42598,7 @@
       </p:sp>
       <p:sp>
         <p:nvSpPr>
-          <p:cNvPr id="1005" name="Rectangle 10"/>
+          <p:cNvPr id="1012" name="Rectangle 10"/>
           <p:cNvSpPr/>
           <p:nvPr/>
         </p:nvSpPr>
@@ -42304,7 +42645,7 @@
       </p:sp>
       <p:sp>
         <p:nvSpPr>
-          <p:cNvPr id="1006" name="Oval 11"/>
+          <p:cNvPr id="1013" name="Oval 11"/>
           <p:cNvSpPr/>
           <p:nvPr/>
         </p:nvSpPr>
@@ -42364,7 +42705,7 @@
       </p:sp>
       <p:sp>
         <p:nvSpPr>
-          <p:cNvPr id="1007" name="Rectangle 12"/>
+          <p:cNvPr id="1014" name="Rectangle 12"/>
           <p:cNvSpPr/>
           <p:nvPr/>
         </p:nvSpPr>
@@ -42422,7 +42763,7 @@
       </p:sp>
       <p:sp>
         <p:nvSpPr>
-          <p:cNvPr id="1008" name="Rectangle 13"/>
+          <p:cNvPr id="1015" name="Rectangle 13"/>
           <p:cNvSpPr/>
           <p:nvPr/>
         </p:nvSpPr>
@@ -42469,7 +42810,7 @@
       </p:sp>
       <p:sp>
         <p:nvSpPr>
-          <p:cNvPr id="1009" name="Oval 14"/>
+          <p:cNvPr id="1016" name="Oval 14"/>
           <p:cNvSpPr/>
           <p:nvPr/>
         </p:nvSpPr>
@@ -42529,7 +42870,7 @@
       </p:sp>
       <p:sp>
         <p:nvSpPr>
-          <p:cNvPr id="1010" name="Rectangle 15"/>
+          <p:cNvPr id="1017" name="Rectangle 15"/>
           <p:cNvSpPr/>
           <p:nvPr/>
         </p:nvSpPr>
@@ -42587,7 +42928,7 @@
       </p:sp>
       <p:sp>
         <p:nvSpPr>
-          <p:cNvPr id="1011" name="Rectangle 16"/>
+          <p:cNvPr id="1018" name="Rectangle 16"/>
           <p:cNvSpPr/>
           <p:nvPr/>
         </p:nvSpPr>
@@ -42632,7 +42973,7 @@
       </p:sp>
       <p:sp>
         <p:nvSpPr>
-          <p:cNvPr id="1012" name="Document"/>
+          <p:cNvPr id="1019" name="Document"/>
           <p:cNvSpPr/>
           <p:nvPr/>
         </p:nvSpPr>
@@ -42750,7 +43091,7 @@
       </p:sp>
       <p:sp>
         <p:nvSpPr>
-          <p:cNvPr id="1013" name="Rectangle 18"/>
+          <p:cNvPr id="1020" name="Rectangle 18"/>
           <p:cNvSpPr/>
           <p:nvPr/>
         </p:nvSpPr>
@@ -42808,7 +43149,7 @@
       </p:sp>
       <p:sp>
         <p:nvSpPr>
-          <p:cNvPr id="1170" name="Slide Number Placeholder"/>
+          <p:cNvPr id="1177" name="Slide Number Placeholder"/>
           <p:cNvSpPr>
             <a:spLocks noGrp="1"/>
           </p:cNvSpPr>
@@ -42855,7 +43196,7 @@
       </p:grpSpPr>
       <p:sp>
         <p:nvSpPr>
-          <p:cNvPr id="1015" name="Rectangle 1"/>
+          <p:cNvPr id="1022" name="Rectangle 1"/>
           <p:cNvSpPr/>
           <p:nvPr/>
         </p:nvSpPr>
@@ -42900,7 +43241,7 @@
       </p:sp>
       <p:sp>
         <p:nvSpPr>
-          <p:cNvPr id="1016" name="Rectangle 2"/>
+          <p:cNvPr id="1023" name="Rectangle 2"/>
           <p:cNvSpPr/>
           <p:nvPr/>
         </p:nvSpPr>
@@ -42958,7 +43299,7 @@
       </p:sp>
       <p:sp>
         <p:nvSpPr>
-          <p:cNvPr id="1017" name="Rectangle 3"/>
+          <p:cNvPr id="1024" name="Rectangle 3"/>
           <p:cNvSpPr/>
           <p:nvPr/>
         </p:nvSpPr>
@@ -43018,7 +43359,7 @@
       </p:sp>
       <p:sp>
         <p:nvSpPr>
-          <p:cNvPr id="1018" name="Rectangle 4"/>
+          <p:cNvPr id="1025" name="Rectangle 4"/>
           <p:cNvSpPr/>
           <p:nvPr/>
         </p:nvSpPr>
@@ -43076,7 +43417,7 @@
       </p:sp>
       <p:sp>
         <p:nvSpPr>
-          <p:cNvPr id="1019" name="Rectangle 5"/>
+          <p:cNvPr id="1026" name="Rectangle 5"/>
           <p:cNvSpPr/>
           <p:nvPr/>
         </p:nvSpPr>
@@ -43134,7 +43475,7 @@
       </p:sp>
       <p:sp>
         <p:nvSpPr>
-          <p:cNvPr id="1020" name="Rectangle 6"/>
+          <p:cNvPr id="1027" name="Rectangle 6"/>
           <p:cNvSpPr/>
           <p:nvPr/>
         </p:nvSpPr>
@@ -43179,7 +43520,7 @@
       </p:sp>
       <p:sp>
         <p:nvSpPr>
-          <p:cNvPr id="1021" name="Rectangle 7"/>
+          <p:cNvPr id="1028" name="Rectangle 7"/>
           <p:cNvSpPr/>
           <p:nvPr/>
         </p:nvSpPr>
@@ -43237,7 +43578,7 @@
       </p:sp>
       <p:sp>
         <p:nvSpPr>
-          <p:cNvPr id="1022" name="Rectangle 8"/>
+          <p:cNvPr id="1029" name="Rectangle 8"/>
           <p:cNvSpPr/>
           <p:nvPr/>
         </p:nvSpPr>
@@ -43295,7 +43636,7 @@
       </p:sp>
       <p:sp>
         <p:nvSpPr>
-          <p:cNvPr id="1023" name="Rectangle 9"/>
+          <p:cNvPr id="1030" name="Rectangle 9"/>
           <p:cNvSpPr/>
           <p:nvPr/>
         </p:nvSpPr>
@@ -43353,7 +43694,7 @@
       </p:sp>
       <p:sp>
         <p:nvSpPr>
-          <p:cNvPr id="1024" name="Rectangle 10"/>
+          <p:cNvPr id="1031" name="Rectangle 10"/>
           <p:cNvSpPr/>
           <p:nvPr/>
         </p:nvSpPr>
@@ -43400,7 +43741,7 @@
       </p:sp>
       <p:sp>
         <p:nvSpPr>
-          <p:cNvPr id="1025" name="Oval 11"/>
+          <p:cNvPr id="1032" name="Oval 11"/>
           <p:cNvSpPr/>
           <p:nvPr/>
         </p:nvSpPr>
@@ -43460,7 +43801,7 @@
       </p:sp>
       <p:sp>
         <p:nvSpPr>
-          <p:cNvPr id="1026" name="Rectangle 12"/>
+          <p:cNvPr id="1033" name="Rectangle 12"/>
           <p:cNvSpPr/>
           <p:nvPr/>
         </p:nvSpPr>
@@ -43518,7 +43859,7 @@
       </p:sp>
       <p:sp>
         <p:nvSpPr>
-          <p:cNvPr id="1027" name="Rectangle 13"/>
+          <p:cNvPr id="1034" name="Rectangle 13"/>
           <p:cNvSpPr/>
           <p:nvPr/>
         </p:nvSpPr>
@@ -43565,7 +43906,7 @@
       </p:sp>
       <p:sp>
         <p:nvSpPr>
-          <p:cNvPr id="1028" name="Oval 14"/>
+          <p:cNvPr id="1035" name="Oval 14"/>
           <p:cNvSpPr/>
           <p:nvPr/>
         </p:nvSpPr>
@@ -43625,7 +43966,7 @@
       </p:sp>
       <p:sp>
         <p:nvSpPr>
-          <p:cNvPr id="1029" name="Rectangle 15"/>
+          <p:cNvPr id="1036" name="Rectangle 15"/>
           <p:cNvSpPr/>
           <p:nvPr/>
         </p:nvSpPr>
@@ -43683,7 +44024,7 @@
       </p:sp>
       <p:sp>
         <p:nvSpPr>
-          <p:cNvPr id="1030" name="Rectangle 16"/>
+          <p:cNvPr id="1037" name="Rectangle 16"/>
           <p:cNvSpPr/>
           <p:nvPr/>
         </p:nvSpPr>
@@ -43728,7 +44069,7 @@
       </p:sp>
       <p:sp>
         <p:nvSpPr>
-          <p:cNvPr id="1031" name="Document"/>
+          <p:cNvPr id="1038" name="Document"/>
           <p:cNvSpPr/>
           <p:nvPr/>
         </p:nvSpPr>
@@ -43846,7 +44187,7 @@
       </p:sp>
       <p:sp>
         <p:nvSpPr>
-          <p:cNvPr id="1032" name="Rectangle 18"/>
+          <p:cNvPr id="1039" name="Rectangle 18"/>
           <p:cNvSpPr/>
           <p:nvPr/>
         </p:nvSpPr>
@@ -43904,7 +44245,7 @@
       </p:sp>
       <p:sp>
         <p:nvSpPr>
-          <p:cNvPr id="1173" name="Slide Number Placeholder"/>
+          <p:cNvPr id="1180" name="Slide Number Placeholder"/>
           <p:cNvSpPr>
             <a:spLocks noGrp="1"/>
           </p:cNvSpPr>
@@ -43951,7 +44292,7 @@
       </p:grpSpPr>
       <p:sp>
         <p:nvSpPr>
-          <p:cNvPr id="1034" name="Rectangle 1"/>
+          <p:cNvPr id="1041" name="Rectangle 1"/>
           <p:cNvSpPr/>
           <p:nvPr/>
         </p:nvSpPr>
@@ -43996,7 +44337,7 @@
       </p:sp>
       <p:sp>
         <p:nvSpPr>
-          <p:cNvPr id="1035" name="Rectangle 2"/>
+          <p:cNvPr id="1042" name="Rectangle 2"/>
           <p:cNvSpPr/>
           <p:nvPr/>
         </p:nvSpPr>
@@ -44054,7 +44395,7 @@
       </p:sp>
       <p:sp>
         <p:nvSpPr>
-          <p:cNvPr id="1036" name="Rectangle 3"/>
+          <p:cNvPr id="1043" name="Rectangle 3"/>
           <p:cNvSpPr/>
           <p:nvPr/>
         </p:nvSpPr>
@@ -44112,7 +44453,7 @@
       </p:sp>
       <p:sp>
         <p:nvSpPr>
-          <p:cNvPr id="1037" name="Rectangle 4"/>
+          <p:cNvPr id="1044" name="Rectangle 4"/>
           <p:cNvSpPr/>
           <p:nvPr/>
         </p:nvSpPr>
@@ -44296,7 +44637,7 @@
       </p:sp>
       <p:sp>
         <p:nvSpPr>
-          <p:cNvPr id="1038" name="Rectangle 5"/>
+          <p:cNvPr id="1045" name="Rectangle 5"/>
           <p:cNvSpPr/>
           <p:nvPr/>
         </p:nvSpPr>
@@ -44480,7 +44821,7 @@
       </p:sp>
       <p:sp>
         <p:nvSpPr>
-          <p:cNvPr id="1039" name="Rectangle 6"/>
+          <p:cNvPr id="1046" name="Rectangle 6"/>
           <p:cNvSpPr/>
           <p:nvPr/>
         </p:nvSpPr>
@@ -44664,7 +45005,7 @@
       </p:sp>
       <p:sp>
         <p:nvSpPr>
-          <p:cNvPr id="1040" name="Rectangle 7"/>
+          <p:cNvPr id="1047" name="Rectangle 7"/>
           <p:cNvSpPr/>
           <p:nvPr/>
         </p:nvSpPr>
@@ -44724,7 +45065,7 @@
       </p:sp>
       <p:sp>
         <p:nvSpPr>
-          <p:cNvPr id="1041" name="Document"/>
+          <p:cNvPr id="1048" name="Document"/>
           <p:cNvSpPr/>
           <p:nvPr/>
         </p:nvSpPr>
@@ -44842,7 +45183,7 @@
       </p:sp>
       <p:sp>
         <p:nvSpPr>
-          <p:cNvPr id="1176" name="Slide Number Placeholder"/>
+          <p:cNvPr id="1183" name="Slide Number Placeholder"/>
           <p:cNvSpPr>
             <a:spLocks noGrp="1"/>
           </p:cNvSpPr>
@@ -46895,7 +47236,7 @@
       </p:sp>
       <p:sp>
         <p:nvSpPr>
-          <p:cNvPr id="1056" name="Slide Number Placeholder"/>
+          <p:cNvPr id="1063" name="Slide Number Placeholder"/>
           <p:cNvSpPr>
             <a:spLocks noGrp="1"/>
           </p:cNvSpPr>
@@ -47471,7 +47812,7 @@
       </p:sp>
       <p:sp>
         <p:nvSpPr>
-          <p:cNvPr id="1059" name="Slide Number Placeholder"/>
+          <p:cNvPr id="1066" name="Slide Number Placeholder"/>
           <p:cNvSpPr>
             <a:spLocks noGrp="1"/>
           </p:cNvSpPr>
@@ -47977,7 +48318,7 @@
       </p:sp>
       <p:sp>
         <p:nvSpPr>
-          <p:cNvPr id="1062" name="Slide Number Placeholder"/>
+          <p:cNvPr id="1069" name="Slide Number Placeholder"/>
           <p:cNvSpPr>
             <a:spLocks noGrp="1"/>
           </p:cNvSpPr>
@@ -48553,7 +48894,7 @@
       </p:sp>
       <p:sp>
         <p:nvSpPr>
-          <p:cNvPr id="1065" name="Slide Number Placeholder"/>
+          <p:cNvPr id="1072" name="Slide Number Placeholder"/>
           <p:cNvSpPr>
             <a:spLocks noGrp="1"/>
           </p:cNvSpPr>
@@ -49017,7 +49358,7 @@
       </p:sp>
       <p:sp>
         <p:nvSpPr>
-          <p:cNvPr id="1068" name="Slide Number Placeholder"/>
+          <p:cNvPr id="1075" name="Slide Number Placeholder"/>
           <p:cNvSpPr>
             <a:spLocks noGrp="1"/>
           </p:cNvSpPr>

</xml_diff>